<commit_message>
docs: sunuma canlı demo adresini ekle
</commit_message>
<xml_diff>
--- a/Quantum_Route_Lab_Sunum_v2.pptx
+++ b/Quantum_Route_Lab_Sunum_v2.pptx
@@ -2,22 +2,22 @@
 <file path=ppt/presentation.xml><?xml version="1.0" encoding="utf-8"?>
 <p:presentation xmlns:p="http://schemas.openxmlformats.org/presentationml/2006/main">
   <p:sldMasterIdLst>
-    <p:sldMasterId xmlns:r="http://schemas.openxmlformats.org/officeDocument/2006/relationships" id="2147483648" r:id="R5b55b3a692a94c41"/>
+    <p:sldMasterId xmlns:r="http://schemas.openxmlformats.org/officeDocument/2006/relationships" id="2147483648" r:id="R210aa44085324963"/>
   </p:sldMasterIdLst>
   <p:notesMasterIdLst>
-    <p:notesMasterId xmlns:r="http://schemas.openxmlformats.org/officeDocument/2006/relationships" r:id="R4a3e3a935d9f47c9"/>
+    <p:notesMasterId xmlns:r="http://schemas.openxmlformats.org/officeDocument/2006/relationships" r:id="Re97bd79dd1f24c52"/>
   </p:notesMasterIdLst>
   <p:sldIdLst>
-    <p:sldId xmlns:r="http://schemas.openxmlformats.org/officeDocument/2006/relationships" id="256" r:id="R3b890d58cef946d8"/>
-    <p:sldId xmlns:r="http://schemas.openxmlformats.org/officeDocument/2006/relationships" id="257" r:id="R760b3778adbc4d13"/>
-    <p:sldId xmlns:r="http://schemas.openxmlformats.org/officeDocument/2006/relationships" id="258" r:id="R5dfb46fb23064a3e"/>
-    <p:sldId xmlns:r="http://schemas.openxmlformats.org/officeDocument/2006/relationships" id="259" r:id="R94d13a072a4449a4"/>
-    <p:sldId xmlns:r="http://schemas.openxmlformats.org/officeDocument/2006/relationships" id="260" r:id="R6e79bf888c3a4334"/>
-    <p:sldId xmlns:r="http://schemas.openxmlformats.org/officeDocument/2006/relationships" id="261" r:id="R0bacaa3bcc244b6e"/>
-    <p:sldId xmlns:r="http://schemas.openxmlformats.org/officeDocument/2006/relationships" id="262" r:id="Rcdfa2a191abe4d06"/>
-    <p:sldId xmlns:r="http://schemas.openxmlformats.org/officeDocument/2006/relationships" id="263" r:id="R57ef73b76c584878"/>
-    <p:sldId xmlns:r="http://schemas.openxmlformats.org/officeDocument/2006/relationships" id="264" r:id="R0547bcd7a15f4750"/>
-    <p:sldId xmlns:r="http://schemas.openxmlformats.org/officeDocument/2006/relationships" id="265" r:id="R27e971e5ec094881"/>
+    <p:sldId xmlns:r="http://schemas.openxmlformats.org/officeDocument/2006/relationships" id="256" r:id="R06c253ba417443d5"/>
+    <p:sldId xmlns:r="http://schemas.openxmlformats.org/officeDocument/2006/relationships" id="257" r:id="R51e129f20a314320"/>
+    <p:sldId xmlns:r="http://schemas.openxmlformats.org/officeDocument/2006/relationships" id="258" r:id="R05fcc9427f8f4053"/>
+    <p:sldId xmlns:r="http://schemas.openxmlformats.org/officeDocument/2006/relationships" id="259" r:id="R933e9a832b164216"/>
+    <p:sldId xmlns:r="http://schemas.openxmlformats.org/officeDocument/2006/relationships" id="260" r:id="R6705b03668674bdb"/>
+    <p:sldId xmlns:r="http://schemas.openxmlformats.org/officeDocument/2006/relationships" id="261" r:id="R8e5fc42822eb46a9"/>
+    <p:sldId xmlns:r="http://schemas.openxmlformats.org/officeDocument/2006/relationships" id="262" r:id="R9c89962e3dc24a07"/>
+    <p:sldId xmlns:r="http://schemas.openxmlformats.org/officeDocument/2006/relationships" id="263" r:id="R3a8b0d4960dd4673"/>
+    <p:sldId xmlns:r="http://schemas.openxmlformats.org/officeDocument/2006/relationships" id="264" r:id="R1b1424f051414a4b"/>
+    <p:sldId xmlns:r="http://schemas.openxmlformats.org/officeDocument/2006/relationships" id="265" r:id="R5279fc2084f842e8"/>
   </p:sldIdLst>
   <p:sldSz cx="12192000" cy="6858000"/>
   <p:notesSz cx="6858000" cy="9144000"/>
@@ -1249,7 +1249,7 @@
   </p:cSld>
   <p:clrMap bg1="lt1" tx1="dk1" bg2="lt2" tx2="dk2" accent1="accent1" accent2="accent2" accent3="accent3" accent4="accent4" accent5="accent5" accent6="accent6" hlink="hlink" folHlink="folHlink"/>
   <p:sldLayoutIdLst>
-    <p:sldLayoutId xmlns:r="http://schemas.openxmlformats.org/officeDocument/2006/relationships" id="2147483649" r:id="R68cba5be301b41b9"/>
+    <p:sldLayoutId xmlns:r="http://schemas.openxmlformats.org/officeDocument/2006/relationships" id="2147483649" r:id="Rbde5e2ec50ea4b2c"/>
   </p:sldLayoutIdLst>
   <p:txStyles>
     <p:titleStyle>
@@ -1800,7 +1800,7 @@
           <p:cNvPr id="8" name="Title-3-1">
             <a:extLst xmlns:a="http://schemas.openxmlformats.org/drawingml/2006/main">
               <a:ext uri="{FF2B5EF4-FFF2-40B4-BE49-F238E27FC236}">
-                <a16:creationId xmlns:a16="http://schemas.microsoft.com/office/drawing/2014/main" id="{5DDFB708-33F3-4273-BFCE-8E11373C1B90}"/>
+                <a16:creationId xmlns:a16="http://schemas.microsoft.com/office/drawing/2014/main" id="{24F5C358-1E76-4DF0-8A22-AAFB59FBD306}"/>
               </a:ext>
             </a:extLst>
           </p:cNvPr>
@@ -1845,7 +1845,7 @@
           <p:cNvPr id="2" name="Subtitle-4-2">
             <a:extLst xmlns:a="http://schemas.openxmlformats.org/drawingml/2006/main">
               <a:ext uri="{FF2B5EF4-FFF2-40B4-BE49-F238E27FC236}">
-                <a16:creationId xmlns:a16="http://schemas.microsoft.com/office/drawing/2014/main" id="{EC7AC5DF-F4E6-4DC1-A53E-3E3D0143451B}"/>
+                <a16:creationId xmlns:a16="http://schemas.microsoft.com/office/drawing/2014/main" id="{5CB6DD6A-F495-4D0F-AB9F-230D0ACAECA2}"/>
               </a:ext>
             </a:extLst>
           </p:cNvPr>
@@ -1890,7 +1890,7 @@
           <p:cNvPr id="3" name="Subtitle-4-3">
             <a:extLst xmlns:a="http://schemas.openxmlformats.org/drawingml/2006/main">
               <a:ext uri="{FF2B5EF4-FFF2-40B4-BE49-F238E27FC236}">
-                <a16:creationId xmlns:a16="http://schemas.microsoft.com/office/drawing/2014/main" id="{842ABA1C-E693-482F-B486-DC2EC4311A87}"/>
+                <a16:creationId xmlns:a16="http://schemas.microsoft.com/office/drawing/2014/main" id="{670803BE-5878-48BA-8663-CA9F2820F857}"/>
               </a:ext>
             </a:extLst>
           </p:cNvPr>
@@ -1935,7 +1935,7 @@
           <p:cNvPr id="4" name="quantum-orbit">
             <a:extLst xmlns:a="http://schemas.openxmlformats.org/drawingml/2006/main">
               <a:ext uri="{FF2B5EF4-FFF2-40B4-BE49-F238E27FC236}">
-                <a16:creationId xmlns:a16="http://schemas.microsoft.com/office/drawing/2014/main" id="{BAB22176-6E12-45B2-91BC-078118CED55C}"/>
+                <a16:creationId xmlns:a16="http://schemas.microsoft.com/office/drawing/2014/main" id="{F37A7D7A-6990-47DA-A2EA-89D5AACB0AAF}"/>
               </a:ext>
             </a:extLst>
           </p:cNvPr>
@@ -1970,7 +1970,7 @@
           <p:cNvPr id="5" name="quantum-psi">
             <a:extLst xmlns:a="http://schemas.openxmlformats.org/drawingml/2006/main">
               <a:ext uri="{FF2B5EF4-FFF2-40B4-BE49-F238E27FC236}">
-                <a16:creationId xmlns:a16="http://schemas.microsoft.com/office/drawing/2014/main" id="{9882A190-0BCE-4E22-A086-4FD17E1DE85B}"/>
+                <a16:creationId xmlns:a16="http://schemas.microsoft.com/office/drawing/2014/main" id="{FD8F44EB-0D6E-4E3E-85DA-FA177ECD867C}"/>
               </a:ext>
             </a:extLst>
           </p:cNvPr>
@@ -2028,7 +2028,7 @@
           <p:cNvPr id="6" name="accent-bar">
             <a:extLst xmlns:a="http://schemas.openxmlformats.org/drawingml/2006/main">
               <a:ext uri="{FF2B5EF4-FFF2-40B4-BE49-F238E27FC236}">
-                <a16:creationId xmlns:a16="http://schemas.microsoft.com/office/drawing/2014/main" id="{65FEF9F8-425F-4C01-BDA5-45700026A33A}"/>
+                <a16:creationId xmlns:a16="http://schemas.microsoft.com/office/drawing/2014/main" id="{1BB5F659-78D4-4D00-B468-D9091CF991E3}"/>
               </a:ext>
             </a:extLst>
           </p:cNvPr>
@@ -2063,7 +2063,7 @@
           <p:cNvPr id="7" name="author">
             <a:extLst xmlns:a="http://schemas.openxmlformats.org/drawingml/2006/main">
               <a:ext uri="{FF2B5EF4-FFF2-40B4-BE49-F238E27FC236}">
-                <a16:creationId xmlns:a16="http://schemas.microsoft.com/office/drawing/2014/main" id="{08213022-061C-48A4-8A8A-96B9D2ED33D9}"/>
+                <a16:creationId xmlns:a16="http://schemas.microsoft.com/office/drawing/2014/main" id="{83AAC775-BE95-4CB8-849C-B4960A6D06BD}"/>
               </a:ext>
             </a:extLst>
           </p:cNvPr>
@@ -2119,7 +2119,7 @@
     </p:spTree>
     <p:extLst>
       <p:ext uri="{BB962C8B-B14F-4D97-AF65-F5344CB8AC3E}">
-        <p14:creationId xmlns:p14="http://schemas.microsoft.com/office/powerpoint/2010/main" val="1661614739"/>
+        <p14:creationId xmlns:p14="http://schemas.microsoft.com/office/powerpoint/2010/main" val="2001610838"/>
       </p:ext>
     </p:extLst>
   </p:cSld>
@@ -2147,10 +2147,10 @@
       </p:grpSpPr>
       <p:sp>
         <p:nvSpPr>
-          <p:cNvPr id="11" name="close-kicker">
-            <a:extLst xmlns:a="http://schemas.openxmlformats.org/drawingml/2006/main">
-              <a:ext uri="{FF2B5EF4-FFF2-40B4-BE49-F238E27FC236}">
-                <a16:creationId xmlns:a16="http://schemas.microsoft.com/office/drawing/2014/main" id="{C8B0B490-B24D-4313-A901-AAFF2F147509}"/>
+          <p:cNvPr id="12" name="close-kicker">
+            <a:extLst xmlns:a="http://schemas.openxmlformats.org/drawingml/2006/main">
+              <a:ext uri="{FF2B5EF4-FFF2-40B4-BE49-F238E27FC236}">
+                <a16:creationId xmlns:a16="http://schemas.microsoft.com/office/drawing/2014/main" id="{02B07BFE-97DF-469D-A174-B83DDA8EB399}"/>
               </a:ext>
             </a:extLst>
           </p:cNvPr>
@@ -2208,7 +2208,7 @@
           <p:cNvPr id="2" name="close-title">
             <a:extLst xmlns:a="http://schemas.openxmlformats.org/drawingml/2006/main">
               <a:ext uri="{FF2B5EF4-FFF2-40B4-BE49-F238E27FC236}">
-                <a16:creationId xmlns:a16="http://schemas.microsoft.com/office/drawing/2014/main" id="{474144B8-679D-421F-9BF5-B03B19FAFAC1}"/>
+                <a16:creationId xmlns:a16="http://schemas.microsoft.com/office/drawing/2014/main" id="{BAC06B30-5822-438E-A85E-E1B04D6946DE}"/>
               </a:ext>
             </a:extLst>
           </p:cNvPr>
@@ -2266,7 +2266,7 @@
           <p:cNvPr id="3" name="close-sub">
             <a:extLst xmlns:a="http://schemas.openxmlformats.org/drawingml/2006/main">
               <a:ext uri="{FF2B5EF4-FFF2-40B4-BE49-F238E27FC236}">
-                <a16:creationId xmlns:a16="http://schemas.microsoft.com/office/drawing/2014/main" id="{1F8E4A27-590F-4BE3-B136-B899045C3391}"/>
+                <a16:creationId xmlns:a16="http://schemas.microsoft.com/office/drawing/2014/main" id="{61FA5D95-1DE6-444F-9134-B83CC727FD24}"/>
               </a:ext>
             </a:extLst>
           </p:cNvPr>
@@ -2324,7 +2324,7 @@
           <p:cNvPr id="4" name="github-box">
             <a:extLst xmlns:a="http://schemas.openxmlformats.org/drawingml/2006/main">
               <a:ext uri="{FF2B5EF4-FFF2-40B4-BE49-F238E27FC236}">
-                <a16:creationId xmlns:a16="http://schemas.microsoft.com/office/drawing/2014/main" id="{70FED798-7FC2-4B20-83BB-2A8C93983C6B}"/>
+                <a16:creationId xmlns:a16="http://schemas.microsoft.com/office/drawing/2014/main" id="{EADE8ACF-14C4-4344-B6C5-CECFD4DEA9CF}"/>
               </a:ext>
             </a:extLst>
           </p:cNvPr>
@@ -2336,7 +2336,7 @@
         <p:spPr>
           <a:xfrm xmlns:a="http://schemas.openxmlformats.org/drawingml/2006/main">
             <a:off x="685800" y="4000500"/>
-            <a:ext cx="7858125" cy="1066800"/>
+            <a:ext cx="4953000" cy="1066800"/>
           </a:xfrm>
           <a:prstGeom xmlns:a="http://schemas.openxmlformats.org/drawingml/2006/main" prst="roundRect">
             <a:avLst>
@@ -2359,7 +2359,7 @@
           <p:cNvPr id="5" name="github-label">
             <a:extLst xmlns:a="http://schemas.openxmlformats.org/drawingml/2006/main">
               <a:ext uri="{FF2B5EF4-FFF2-40B4-BE49-F238E27FC236}">
-                <a16:creationId xmlns:a16="http://schemas.microsoft.com/office/drawing/2014/main" id="{917444C3-9494-40A1-8634-19A7BFBA8725}"/>
+                <a16:creationId xmlns:a16="http://schemas.microsoft.com/office/drawing/2014/main" id="{A1F386C9-3CC5-4653-8FBE-C84750A30096}"/>
               </a:ext>
             </a:extLst>
           </p:cNvPr>
@@ -2417,19 +2417,19 @@
           <p:cNvPr id="6" name="github-url">
             <a:extLst xmlns:a="http://schemas.openxmlformats.org/drawingml/2006/main">
               <a:ext uri="{FF2B5EF4-FFF2-40B4-BE49-F238E27FC236}">
-                <a16:creationId xmlns:a16="http://schemas.microsoft.com/office/drawing/2014/main" id="{79C9CC92-73D3-4DDF-86B3-24441C0B818F}"/>
-              </a:ext>
-            </a:extLst>
-          </p:cNvPr>
-          <p:cNvSpPr>
-            <a:spLocks xmlns:a="http://schemas.openxmlformats.org/drawingml/2006/main" noGrp="1"/>
-          </p:cNvSpPr>
-          <p:nvPr/>
-        </p:nvSpPr>
-        <p:spPr>
-          <a:xfrm xmlns:a="http://schemas.openxmlformats.org/drawingml/2006/main">
-            <a:off x="990600" y="4533900"/>
-            <a:ext cx="7096125" cy="323850"/>
+                <a16:creationId xmlns:a16="http://schemas.microsoft.com/office/drawing/2014/main" id="{36E33CDE-5E3D-4E12-94BE-0C0DB647FFE9}"/>
+              </a:ext>
+            </a:extLst>
+          </p:cNvPr>
+          <p:cNvSpPr>
+            <a:spLocks xmlns:a="http://schemas.openxmlformats.org/drawingml/2006/main" noGrp="1"/>
+          </p:cNvSpPr>
+          <p:nvPr/>
+        </p:nvSpPr>
+        <p:spPr>
+          <a:xfrm xmlns:a="http://schemas.openxmlformats.org/drawingml/2006/main">
+            <a:off x="990600" y="4514850"/>
+            <a:ext cx="4248150" cy="438150"/>
           </a:xfrm>
           <a:prstGeom xmlns:a="http://schemas.openxmlformats.org/drawingml/2006/main" prst="rect">
             <a:avLst/>
@@ -2442,12 +2442,12 @@
         </p:spPr>
         <p:txBody>
           <a:bodyPr xmlns:a="http://schemas.openxmlformats.org/drawingml/2006/main" anchor="t">
-            <a:normAutofit fontScale="100000"/>
+            <a:normAutofit fontScale="94792"/>
           </a:bodyPr>
           <a:lstStyle xmlns:a="http://schemas.openxmlformats.org/drawingml/2006/main"/>
           <a:p xmlns:a="http://schemas.openxmlformats.org/drawingml/2006/main">
             <a:pPr>
-              <a:defRPr sz="1500" b="1">
+              <a:defRPr sz="1200" b="1">
                 <a:solidFill>
                   <a:srgbClr val="FFFFFF"/>
                 </a:solidFill>
@@ -2457,7 +2457,7 @@
               </a:defRPr>
             </a:pPr>
             <a:r>
-              <a:rPr sz="1500" b="1">
+              <a:rPr sz="1200" b="1">
                 <a:solidFill>
                   <a:srgbClr val="FFFFFF"/>
                 </a:solidFill>
@@ -2465,29 +2465,52 @@
                 <a:ea typeface="Aptos"/>
                 <a:cs typeface="Aptos"/>
               </a:rPr>
-              <a:t>github.com/fatmaturkmen244-spec/kuantum-hibrit-optimizasyon</a:t>
-            </a:r>
-          </a:p>
-        </p:txBody>
-      </p:sp>
-      <p:sp>
-        <p:nvSpPr>
-          <p:cNvPr id="7" name="ask-box">
-            <a:extLst xmlns:a="http://schemas.openxmlformats.org/drawingml/2006/main">
-              <a:ext uri="{FF2B5EF4-FFF2-40B4-BE49-F238E27FC236}">
-                <a16:creationId xmlns:a16="http://schemas.microsoft.com/office/drawing/2014/main" id="{F6C6D922-4A8E-4D03-B298-44DA499CFB62}"/>
-              </a:ext>
-            </a:extLst>
-          </p:cNvPr>
-          <p:cNvSpPr>
-            <a:spLocks xmlns:a="http://schemas.openxmlformats.org/drawingml/2006/main" noGrp="1"/>
-          </p:cNvSpPr>
-          <p:nvPr/>
-        </p:nvSpPr>
-        <p:spPr>
-          <a:xfrm xmlns:a="http://schemas.openxmlformats.org/drawingml/2006/main">
-            <a:off x="8934450" y="4000500"/>
-            <a:ext cx="2571750" cy="1066800"/>
+              <a:t>github.com/fatmaturkmen244-spec/</a:t>
+            </a:r>
+          </a:p>
+          <a:p xmlns:a="http://schemas.openxmlformats.org/drawingml/2006/main">
+            <a:pPr>
+              <a:defRPr sz="1200" b="1">
+                <a:solidFill>
+                  <a:srgbClr val="FFFFFF"/>
+                </a:solidFill>
+                <a:latin typeface="Aptos"/>
+                <a:ea typeface="Aptos"/>
+                <a:cs typeface="Aptos"/>
+              </a:defRPr>
+            </a:pPr>
+            <a:r>
+              <a:rPr sz="1200" b="1">
+                <a:solidFill>
+                  <a:srgbClr val="FFFFFF"/>
+                </a:solidFill>
+                <a:latin typeface="Aptos"/>
+                <a:ea typeface="Aptos"/>
+                <a:cs typeface="Aptos"/>
+              </a:rPr>
+              <a:t>kuantum-hibrit-optimizasyon</a:t>
+            </a:r>
+          </a:p>
+        </p:txBody>
+      </p:sp>
+      <p:sp>
+        <p:nvSpPr>
+          <p:cNvPr id="7" name="live-box">
+            <a:extLst xmlns:a="http://schemas.openxmlformats.org/drawingml/2006/main">
+              <a:ext uri="{FF2B5EF4-FFF2-40B4-BE49-F238E27FC236}">
+                <a16:creationId xmlns:a16="http://schemas.microsoft.com/office/drawing/2014/main" id="{E7FE29A8-C818-4603-9A29-69024CD262CA}"/>
+              </a:ext>
+            </a:extLst>
+          </p:cNvPr>
+          <p:cNvSpPr>
+            <a:spLocks xmlns:a="http://schemas.openxmlformats.org/drawingml/2006/main" noGrp="1"/>
+          </p:cNvSpPr>
+          <p:nvPr/>
+        </p:nvSpPr>
+        <p:spPr>
+          <a:xfrm xmlns:a="http://schemas.openxmlformats.org/drawingml/2006/main">
+            <a:off x="5981700" y="4000500"/>
+            <a:ext cx="5524500" cy="1066800"/>
           </a:xfrm>
           <a:prstGeom xmlns:a="http://schemas.openxmlformats.org/drawingml/2006/main" prst="roundRect">
             <a:avLst>
@@ -2507,22 +2530,22 @@
       </p:sp>
       <p:sp>
         <p:nvSpPr>
-          <p:cNvPr id="8" name="ask">
-            <a:extLst xmlns:a="http://schemas.openxmlformats.org/drawingml/2006/main">
-              <a:ext uri="{FF2B5EF4-FFF2-40B4-BE49-F238E27FC236}">
-                <a16:creationId xmlns:a16="http://schemas.microsoft.com/office/drawing/2014/main" id="{707D604A-1B05-4F4E-98A6-89FBB9245DC3}"/>
-              </a:ext>
-            </a:extLst>
-          </p:cNvPr>
-          <p:cNvSpPr>
-            <a:spLocks xmlns:a="http://schemas.openxmlformats.org/drawingml/2006/main" noGrp="1"/>
-          </p:cNvSpPr>
-          <p:nvPr/>
-        </p:nvSpPr>
-        <p:spPr>
-          <a:xfrm xmlns:a="http://schemas.openxmlformats.org/drawingml/2006/main">
-            <a:off x="9248775" y="4248150"/>
-            <a:ext cx="1943100" cy="590550"/>
+          <p:cNvPr id="8" name="live-label">
+            <a:extLst xmlns:a="http://schemas.openxmlformats.org/drawingml/2006/main">
+              <a:ext uri="{FF2B5EF4-FFF2-40B4-BE49-F238E27FC236}">
+                <a16:creationId xmlns:a16="http://schemas.microsoft.com/office/drawing/2014/main" id="{91FF3877-D294-4081-BDD3-0E853E7BA3A0}"/>
+              </a:ext>
+            </a:extLst>
+          </p:cNvPr>
+          <p:cNvSpPr>
+            <a:spLocks xmlns:a="http://schemas.openxmlformats.org/drawingml/2006/main" noGrp="1"/>
+          </p:cNvSpPr>
+          <p:nvPr/>
+        </p:nvSpPr>
+        <p:spPr>
+          <a:xfrm xmlns:a="http://schemas.openxmlformats.org/drawingml/2006/main">
+            <a:off x="6286500" y="4248150"/>
+            <a:ext cx="1428750" cy="190500"/>
           </a:xfrm>
           <a:prstGeom xmlns:a="http://schemas.openxmlformats.org/drawingml/2006/main" prst="rect">
             <a:avLst/>
@@ -2535,75 +2558,52 @@
         </p:spPr>
         <p:txBody>
           <a:bodyPr xmlns:a="http://schemas.openxmlformats.org/drawingml/2006/main" anchor="t">
-            <a:normAutofit fontScale="90972"/>
-          </a:bodyPr>
-          <a:lstStyle xmlns:a="http://schemas.openxmlformats.org/drawingml/2006/main"/>
-          <a:p xmlns:a="http://schemas.openxmlformats.org/drawingml/2006/main">
-            <a:pPr algn="ctr">
-              <a:defRPr sz="1800" b="1">
-                <a:solidFill>
-                  <a:srgbClr val="FFFFFF"/>
-                </a:solidFill>
-                <a:latin typeface="Aptos"/>
-                <a:ea typeface="Aptos"/>
-                <a:cs typeface="Aptos"/>
-              </a:defRPr>
-            </a:pPr>
-            <a:r>
-              <a:rPr sz="1800" b="1">
-                <a:solidFill>
-                  <a:srgbClr val="FFFFFF"/>
+            <a:normAutofit fontScale="72222"/>
+          </a:bodyPr>
+          <a:lstStyle xmlns:a="http://schemas.openxmlformats.org/drawingml/2006/main"/>
+          <a:p xmlns:a="http://schemas.openxmlformats.org/drawingml/2006/main">
+            <a:pPr>
+              <a:defRPr sz="900" b="1">
+                <a:solidFill>
+                  <a:srgbClr val="DFF9FF"/>
+                </a:solidFill>
+                <a:latin typeface="Aptos"/>
+                <a:ea typeface="Aptos"/>
+                <a:cs typeface="Aptos"/>
+              </a:defRPr>
+            </a:pPr>
+            <a:r>
+              <a:rPr sz="900" b="1">
+                <a:solidFill>
+                  <a:srgbClr val="DFF9FF"/>
                 </a:solidFill>
                 <a:latin typeface="Aptos"/>
                 <a:ea typeface="Aptos"/>
                 <a:cs typeface="Aptos"/>
               </a:rPr>
-              <a:t>Canlı demoya</a:t>
-            </a:r>
-          </a:p>
-          <a:p xmlns:a="http://schemas.openxmlformats.org/drawingml/2006/main">
-            <a:pPr algn="ctr">
-              <a:defRPr sz="1800" b="1">
-                <a:solidFill>
-                  <a:srgbClr val="FFFFFF"/>
-                </a:solidFill>
-                <a:latin typeface="Aptos"/>
-                <a:ea typeface="Aptos"/>
-                <a:cs typeface="Aptos"/>
-              </a:defRPr>
-            </a:pPr>
-            <a:r>
-              <a:rPr sz="1800" b="1">
-                <a:solidFill>
-                  <a:srgbClr val="FFFFFF"/>
-                </a:solidFill>
-                <a:latin typeface="Aptos"/>
-                <a:ea typeface="Aptos"/>
-                <a:cs typeface="Aptos"/>
-              </a:rPr>
-              <a:t>geçelim</a:t>
-            </a:r>
-          </a:p>
-        </p:txBody>
-      </p:sp>
-      <p:sp>
-        <p:nvSpPr>
-          <p:cNvPr id="9" name="close-question">
-            <a:extLst xmlns:a="http://schemas.openxmlformats.org/drawingml/2006/main">
-              <a:ext uri="{FF2B5EF4-FFF2-40B4-BE49-F238E27FC236}">
-                <a16:creationId xmlns:a16="http://schemas.microsoft.com/office/drawing/2014/main" id="{7D83101A-8FB8-4E77-A8B2-1EE123083F44}"/>
-              </a:ext>
-            </a:extLst>
-          </p:cNvPr>
-          <p:cNvSpPr>
-            <a:spLocks xmlns:a="http://schemas.openxmlformats.org/drawingml/2006/main" noGrp="1"/>
-          </p:cNvSpPr>
-          <p:nvPr/>
-        </p:nvSpPr>
-        <p:spPr>
-          <a:xfrm xmlns:a="http://schemas.openxmlformats.org/drawingml/2006/main">
-            <a:off x="685800" y="5657850"/>
-            <a:ext cx="10477500" cy="457200"/>
+              <a:t>CANLI DEMO</a:t>
+            </a:r>
+          </a:p>
+        </p:txBody>
+      </p:sp>
+      <p:sp>
+        <p:nvSpPr>
+          <p:cNvPr id="9" name="live-url">
+            <a:extLst xmlns:a="http://schemas.openxmlformats.org/drawingml/2006/main">
+              <a:ext uri="{FF2B5EF4-FFF2-40B4-BE49-F238E27FC236}">
+                <a16:creationId xmlns:a16="http://schemas.microsoft.com/office/drawing/2014/main" id="{0D3EF0AF-4046-4C02-9C14-26F18C5E9592}"/>
+              </a:ext>
+            </a:extLst>
+          </p:cNvPr>
+          <p:cNvSpPr>
+            <a:spLocks xmlns:a="http://schemas.openxmlformats.org/drawingml/2006/main" noGrp="1"/>
+          </p:cNvSpPr>
+          <p:nvPr/>
+        </p:nvSpPr>
+        <p:spPr>
+          <a:xfrm xmlns:a="http://schemas.openxmlformats.org/drawingml/2006/main">
+            <a:off x="6286500" y="4514850"/>
+            <a:ext cx="4762500" cy="438150"/>
           </a:xfrm>
           <a:prstGeom xmlns:a="http://schemas.openxmlformats.org/drawingml/2006/main" prst="rect">
             <a:avLst/>
@@ -2616,52 +2616,75 @@
         </p:spPr>
         <p:txBody>
           <a:bodyPr xmlns:a="http://schemas.openxmlformats.org/drawingml/2006/main" anchor="t">
-            <a:normAutofit fontScale="100000"/>
+            <a:normAutofit fontScale="94792"/>
           </a:bodyPr>
           <a:lstStyle xmlns:a="http://schemas.openxmlformats.org/drawingml/2006/main"/>
           <a:p xmlns:a="http://schemas.openxmlformats.org/drawingml/2006/main">
             <a:pPr>
-              <a:defRPr sz="1350">
-                <a:solidFill>
-                  <a:srgbClr val="16BDEB"/>
-                </a:solidFill>
-                <a:latin typeface="Aptos"/>
-                <a:ea typeface="Aptos"/>
-                <a:cs typeface="Aptos"/>
-              </a:defRPr>
-            </a:pPr>
-            <a:r>
-              <a:rPr sz="1350">
-                <a:solidFill>
-                  <a:srgbClr val="16BDEB"/>
+              <a:defRPr sz="1200" b="1">
+                <a:solidFill>
+                  <a:srgbClr val="FFFFFF"/>
+                </a:solidFill>
+                <a:latin typeface="Aptos"/>
+                <a:ea typeface="Aptos"/>
+                <a:cs typeface="Aptos"/>
+              </a:defRPr>
+            </a:pPr>
+            <a:r>
+              <a:rPr sz="1200" b="1">
+                <a:solidFill>
+                  <a:srgbClr val="FFFFFF"/>
                 </a:solidFill>
                 <a:latin typeface="Aptos"/>
                 <a:ea typeface="Aptos"/>
                 <a:cs typeface="Aptos"/>
               </a:rPr>
-              <a:t>Soru: Kuantum hangi problemde gerçekten avantaj sağlayacak? Cevabı varsaymıyoruz — benchmark ediyoruz.</a:t>
-            </a:r>
-          </a:p>
-        </p:txBody>
-      </p:sp>
-      <p:sp>
-        <p:nvSpPr>
-          <p:cNvPr id="10" name="page-10">
-            <a:extLst xmlns:a="http://schemas.openxmlformats.org/drawingml/2006/main">
-              <a:ext uri="{FF2B5EF4-FFF2-40B4-BE49-F238E27FC236}">
-                <a16:creationId xmlns:a16="http://schemas.microsoft.com/office/drawing/2014/main" id="{C642FA8A-BFD4-42DA-9FAC-8B9F598AB629}"/>
-              </a:ext>
-            </a:extLst>
-          </p:cNvPr>
-          <p:cNvSpPr>
-            <a:spLocks xmlns:a="http://schemas.openxmlformats.org/drawingml/2006/main" noGrp="1"/>
-          </p:cNvSpPr>
-          <p:nvPr/>
-        </p:nvSpPr>
-        <p:spPr>
-          <a:xfrm xmlns:a="http://schemas.openxmlformats.org/drawingml/2006/main">
-            <a:off x="11334750" y="6419850"/>
-            <a:ext cx="304800" cy="171450"/>
+              <a:t>fatmaturkmen244-spec.github.io/</a:t>
+            </a:r>
+          </a:p>
+          <a:p xmlns:a="http://schemas.openxmlformats.org/drawingml/2006/main">
+            <a:pPr>
+              <a:defRPr sz="1200" b="1">
+                <a:solidFill>
+                  <a:srgbClr val="FFFFFF"/>
+                </a:solidFill>
+                <a:latin typeface="Aptos"/>
+                <a:ea typeface="Aptos"/>
+                <a:cs typeface="Aptos"/>
+              </a:defRPr>
+            </a:pPr>
+            <a:r>
+              <a:rPr sz="1200" b="1">
+                <a:solidFill>
+                  <a:srgbClr val="FFFFFF"/>
+                </a:solidFill>
+                <a:latin typeface="Aptos"/>
+                <a:ea typeface="Aptos"/>
+                <a:cs typeface="Aptos"/>
+              </a:rPr>
+              <a:t>kuantum-hibrit-optimizasyon/</a:t>
+            </a:r>
+          </a:p>
+        </p:txBody>
+      </p:sp>
+      <p:sp>
+        <p:nvSpPr>
+          <p:cNvPr id="10" name="close-question">
+            <a:extLst xmlns:a="http://schemas.openxmlformats.org/drawingml/2006/main">
+              <a:ext uri="{FF2B5EF4-FFF2-40B4-BE49-F238E27FC236}">
+                <a16:creationId xmlns:a16="http://schemas.microsoft.com/office/drawing/2014/main" id="{7C0748C8-3F38-4068-B35B-4935726D1D46}"/>
+              </a:ext>
+            </a:extLst>
+          </p:cNvPr>
+          <p:cNvSpPr>
+            <a:spLocks xmlns:a="http://schemas.openxmlformats.org/drawingml/2006/main" noGrp="1"/>
+          </p:cNvSpPr>
+          <p:nvPr/>
+        </p:nvSpPr>
+        <p:spPr>
+          <a:xfrm xmlns:a="http://schemas.openxmlformats.org/drawingml/2006/main">
+            <a:off x="685800" y="5657850"/>
+            <a:ext cx="10477500" cy="457200"/>
           </a:xfrm>
           <a:prstGeom xmlns:a="http://schemas.openxmlformats.org/drawingml/2006/main" prst="rect">
             <a:avLst/>
@@ -2674,6 +2697,64 @@
         </p:spPr>
         <p:txBody>
           <a:bodyPr xmlns:a="http://schemas.openxmlformats.org/drawingml/2006/main" anchor="t">
+            <a:normAutofit fontScale="100000"/>
+          </a:bodyPr>
+          <a:lstStyle xmlns:a="http://schemas.openxmlformats.org/drawingml/2006/main"/>
+          <a:p xmlns:a="http://schemas.openxmlformats.org/drawingml/2006/main">
+            <a:pPr>
+              <a:defRPr sz="1350">
+                <a:solidFill>
+                  <a:srgbClr val="16BDEB"/>
+                </a:solidFill>
+                <a:latin typeface="Aptos"/>
+                <a:ea typeface="Aptos"/>
+                <a:cs typeface="Aptos"/>
+              </a:defRPr>
+            </a:pPr>
+            <a:r>
+              <a:rPr sz="1350">
+                <a:solidFill>
+                  <a:srgbClr val="16BDEB"/>
+                </a:solidFill>
+                <a:latin typeface="Aptos"/>
+                <a:ea typeface="Aptos"/>
+                <a:cs typeface="Aptos"/>
+              </a:rPr>
+              <a:t>Soru: Kuantum hangi problemde gerçekten avantaj sağlayacak? Cevabı varsaymıyoruz — benchmark ediyoruz.</a:t>
+            </a:r>
+          </a:p>
+        </p:txBody>
+      </p:sp>
+      <p:sp>
+        <p:nvSpPr>
+          <p:cNvPr id="11" name="page-10">
+            <a:extLst xmlns:a="http://schemas.openxmlformats.org/drawingml/2006/main">
+              <a:ext uri="{FF2B5EF4-FFF2-40B4-BE49-F238E27FC236}">
+                <a16:creationId xmlns:a16="http://schemas.microsoft.com/office/drawing/2014/main" id="{8C1105B0-B7DA-4714-BA60-EC7A75056E6A}"/>
+              </a:ext>
+            </a:extLst>
+          </p:cNvPr>
+          <p:cNvSpPr>
+            <a:spLocks xmlns:a="http://schemas.openxmlformats.org/drawingml/2006/main" noGrp="1"/>
+          </p:cNvSpPr>
+          <p:nvPr/>
+        </p:nvSpPr>
+        <p:spPr>
+          <a:xfrm xmlns:a="http://schemas.openxmlformats.org/drawingml/2006/main">
+            <a:off x="11334750" y="6419850"/>
+            <a:ext cx="304800" cy="171450"/>
+          </a:xfrm>
+          <a:prstGeom xmlns:a="http://schemas.openxmlformats.org/drawingml/2006/main" prst="rect">
+            <a:avLst/>
+          </a:prstGeom>
+          <a:noFill xmlns:a="http://schemas.openxmlformats.org/drawingml/2006/main"/>
+          <a:ln xmlns:a="http://schemas.openxmlformats.org/drawingml/2006/main" w="0">
+            <a:noFill/>
+            <a:prstDash val="solid"/>
+          </a:ln>
+        </p:spPr>
+        <p:txBody>
+          <a:bodyPr xmlns:a="http://schemas.openxmlformats.org/drawingml/2006/main" anchor="t">
             <a:normAutofit fontScale="63636"/>
           </a:bodyPr>
           <a:lstStyle xmlns:a="http://schemas.openxmlformats.org/drawingml/2006/main"/>
@@ -2705,7 +2786,7 @@
     </p:spTree>
     <p:extLst>
       <p:ext uri="{BB962C8B-B14F-4D97-AF65-F5344CB8AC3E}">
-        <p14:creationId xmlns:p14="http://schemas.microsoft.com/office/powerpoint/2010/main" val="811050532"/>
+        <p14:creationId xmlns:p14="http://schemas.microsoft.com/office/powerpoint/2010/main" val="1335109581"/>
       </p:ext>
     </p:extLst>
   </p:cSld>
@@ -2736,7 +2817,7 @@
           <p:cNvPr id="21" name="Problem-eyebrow">
             <a:extLst xmlns:a="http://schemas.openxmlformats.org/drawingml/2006/main">
               <a:ext uri="{FF2B5EF4-FFF2-40B4-BE49-F238E27FC236}">
-                <a16:creationId xmlns:a16="http://schemas.microsoft.com/office/drawing/2014/main" id="{DD835710-24DC-405B-BF9A-E2CDAAF80EED}"/>
+                <a16:creationId xmlns:a16="http://schemas.microsoft.com/office/drawing/2014/main" id="{DF08DA17-54DA-4620-BF16-6B7E4BD691BA}"/>
               </a:ext>
             </a:extLst>
           </p:cNvPr>
@@ -2794,7 +2875,7 @@
           <p:cNvPr id="2" name="Problem-title">
             <a:extLst xmlns:a="http://schemas.openxmlformats.org/drawingml/2006/main">
               <a:ext uri="{FF2B5EF4-FFF2-40B4-BE49-F238E27FC236}">
-                <a16:creationId xmlns:a16="http://schemas.microsoft.com/office/drawing/2014/main" id="{3FAEA7D0-D51A-4804-80B9-478DFC28698C}"/>
+                <a16:creationId xmlns:a16="http://schemas.microsoft.com/office/drawing/2014/main" id="{8BD8D4E1-D0DD-4A46-B5F7-8928FECAE412}"/>
               </a:ext>
             </a:extLst>
           </p:cNvPr>
@@ -2852,7 +2933,7 @@
           <p:cNvPr id="3" name="Problem-subtitle">
             <a:extLst xmlns:a="http://schemas.openxmlformats.org/drawingml/2006/main">
               <a:ext uri="{FF2B5EF4-FFF2-40B4-BE49-F238E27FC236}">
-                <a16:creationId xmlns:a16="http://schemas.microsoft.com/office/drawing/2014/main" id="{228D6386-E0C4-4384-9C98-7C39BA56C76B}"/>
+                <a16:creationId xmlns:a16="http://schemas.microsoft.com/office/drawing/2014/main" id="{28A07925-ECA5-4A67-B6E5-339351822EAA}"/>
               </a:ext>
             </a:extLst>
           </p:cNvPr>
@@ -2910,7 +2991,7 @@
           <p:cNvPr id="4" name="growth-0">
             <a:extLst xmlns:a="http://schemas.openxmlformats.org/drawingml/2006/main">
               <a:ext uri="{FF2B5EF4-FFF2-40B4-BE49-F238E27FC236}">
-                <a16:creationId xmlns:a16="http://schemas.microsoft.com/office/drawing/2014/main" id="{33AF3129-F2F9-4215-91D0-9A6DB0070B36}"/>
+                <a16:creationId xmlns:a16="http://schemas.microsoft.com/office/drawing/2014/main" id="{F9B4D342-8E04-48BE-88DB-B5B4F6BEDFC6}"/>
               </a:ext>
             </a:extLst>
           </p:cNvPr>
@@ -2945,7 +3026,7 @@
           <p:cNvPr id="5" name="growth-label-0">
             <a:extLst xmlns:a="http://schemas.openxmlformats.org/drawingml/2006/main">
               <a:ext uri="{FF2B5EF4-FFF2-40B4-BE49-F238E27FC236}">
-                <a16:creationId xmlns:a16="http://schemas.microsoft.com/office/drawing/2014/main" id="{129A019F-78EF-4792-B08E-444FE4E07337}"/>
+                <a16:creationId xmlns:a16="http://schemas.microsoft.com/office/drawing/2014/main" id="{B034F56C-4149-4D7C-90A4-80A3AC445789}"/>
               </a:ext>
             </a:extLst>
           </p:cNvPr>
@@ -3003,7 +3084,7 @@
           <p:cNvPr id="6" name="growth-value-0">
             <a:extLst xmlns:a="http://schemas.openxmlformats.org/drawingml/2006/main">
               <a:ext uri="{FF2B5EF4-FFF2-40B4-BE49-F238E27FC236}">
-                <a16:creationId xmlns:a16="http://schemas.microsoft.com/office/drawing/2014/main" id="{618628E8-000C-4B04-ADF8-CADD253E64A0}"/>
+                <a16:creationId xmlns:a16="http://schemas.microsoft.com/office/drawing/2014/main" id="{76895AC6-71AC-4F0C-9B38-672F891C3D2E}"/>
               </a:ext>
             </a:extLst>
           </p:cNvPr>
@@ -3061,7 +3142,7 @@
           <p:cNvPr id="7" name="growth-unit-0">
             <a:extLst xmlns:a="http://schemas.openxmlformats.org/drawingml/2006/main">
               <a:ext uri="{FF2B5EF4-FFF2-40B4-BE49-F238E27FC236}">
-                <a16:creationId xmlns:a16="http://schemas.microsoft.com/office/drawing/2014/main" id="{AF9518D9-25FE-4C3D-8804-D04920A48A8B}"/>
+                <a16:creationId xmlns:a16="http://schemas.microsoft.com/office/drawing/2014/main" id="{F8AEF1B4-0D37-4E70-9349-D7F1B8F896F6}"/>
               </a:ext>
             </a:extLst>
           </p:cNvPr>
@@ -3119,7 +3200,7 @@
           <p:cNvPr id="8" name="growth-1">
             <a:extLst xmlns:a="http://schemas.openxmlformats.org/drawingml/2006/main">
               <a:ext uri="{FF2B5EF4-FFF2-40B4-BE49-F238E27FC236}">
-                <a16:creationId xmlns:a16="http://schemas.microsoft.com/office/drawing/2014/main" id="{55114C93-E2D0-4D9B-A797-9F2F95C8EB19}"/>
+                <a16:creationId xmlns:a16="http://schemas.microsoft.com/office/drawing/2014/main" id="{C98F8EC3-D141-42FF-BF68-4B3CD94D08DF}"/>
               </a:ext>
             </a:extLst>
           </p:cNvPr>
@@ -3154,7 +3235,7 @@
           <p:cNvPr id="9" name="growth-label-1">
             <a:extLst xmlns:a="http://schemas.openxmlformats.org/drawingml/2006/main">
               <a:ext uri="{FF2B5EF4-FFF2-40B4-BE49-F238E27FC236}">
-                <a16:creationId xmlns:a16="http://schemas.microsoft.com/office/drawing/2014/main" id="{313A4848-75E2-42C3-A371-16B45DA9695D}"/>
+                <a16:creationId xmlns:a16="http://schemas.microsoft.com/office/drawing/2014/main" id="{922022A2-759A-4CFE-ACA3-F3E403094F69}"/>
               </a:ext>
             </a:extLst>
           </p:cNvPr>
@@ -3212,7 +3293,7 @@
           <p:cNvPr id="10" name="growth-value-1">
             <a:extLst xmlns:a="http://schemas.openxmlformats.org/drawingml/2006/main">
               <a:ext uri="{FF2B5EF4-FFF2-40B4-BE49-F238E27FC236}">
-                <a16:creationId xmlns:a16="http://schemas.microsoft.com/office/drawing/2014/main" id="{A7631120-DE5B-40F2-BDE4-0DD055B115EF}"/>
+                <a16:creationId xmlns:a16="http://schemas.microsoft.com/office/drawing/2014/main" id="{FE432D9E-3943-4788-BF18-9236FCE9070C}"/>
               </a:ext>
             </a:extLst>
           </p:cNvPr>
@@ -3270,7 +3351,7 @@
           <p:cNvPr id="11" name="growth-unit-1">
             <a:extLst xmlns:a="http://schemas.openxmlformats.org/drawingml/2006/main">
               <a:ext uri="{FF2B5EF4-FFF2-40B4-BE49-F238E27FC236}">
-                <a16:creationId xmlns:a16="http://schemas.microsoft.com/office/drawing/2014/main" id="{48ED5139-6857-428B-BDE2-BCCC11D66BD9}"/>
+                <a16:creationId xmlns:a16="http://schemas.microsoft.com/office/drawing/2014/main" id="{DDEDC5A5-B0DA-4D71-9DC6-EEE7E8C84364}"/>
               </a:ext>
             </a:extLst>
           </p:cNvPr>
@@ -3328,7 +3409,7 @@
           <p:cNvPr id="12" name="growth-2">
             <a:extLst xmlns:a="http://schemas.openxmlformats.org/drawingml/2006/main">
               <a:ext uri="{FF2B5EF4-FFF2-40B4-BE49-F238E27FC236}">
-                <a16:creationId xmlns:a16="http://schemas.microsoft.com/office/drawing/2014/main" id="{EC6DE413-C688-4610-81D2-56704C27A153}"/>
+                <a16:creationId xmlns:a16="http://schemas.microsoft.com/office/drawing/2014/main" id="{EF77F660-7EAF-4188-890E-F1622334E5C0}"/>
               </a:ext>
             </a:extLst>
           </p:cNvPr>
@@ -3363,7 +3444,7 @@
           <p:cNvPr id="13" name="growth-label-2">
             <a:extLst xmlns:a="http://schemas.openxmlformats.org/drawingml/2006/main">
               <a:ext uri="{FF2B5EF4-FFF2-40B4-BE49-F238E27FC236}">
-                <a16:creationId xmlns:a16="http://schemas.microsoft.com/office/drawing/2014/main" id="{474662E2-2348-45BC-B2EB-A0D2AC7225B3}"/>
+                <a16:creationId xmlns:a16="http://schemas.microsoft.com/office/drawing/2014/main" id="{1FA6ABF6-23D6-46DC-9122-CD7926E70FD5}"/>
               </a:ext>
             </a:extLst>
           </p:cNvPr>
@@ -3421,7 +3502,7 @@
           <p:cNvPr id="14" name="growth-value-2">
             <a:extLst xmlns:a="http://schemas.openxmlformats.org/drawingml/2006/main">
               <a:ext uri="{FF2B5EF4-FFF2-40B4-BE49-F238E27FC236}">
-                <a16:creationId xmlns:a16="http://schemas.microsoft.com/office/drawing/2014/main" id="{0483454E-8977-403B-B011-BDB27632D562}"/>
+                <a16:creationId xmlns:a16="http://schemas.microsoft.com/office/drawing/2014/main" id="{11AE9BEE-0F6C-40F1-9035-5A45BB772032}"/>
               </a:ext>
             </a:extLst>
           </p:cNvPr>
@@ -3479,7 +3560,7 @@
           <p:cNvPr id="15" name="growth-unit-2">
             <a:extLst xmlns:a="http://schemas.openxmlformats.org/drawingml/2006/main">
               <a:ext uri="{FF2B5EF4-FFF2-40B4-BE49-F238E27FC236}">
-                <a16:creationId xmlns:a16="http://schemas.microsoft.com/office/drawing/2014/main" id="{8C49F4C6-DF0C-40A7-99B5-B0775769226C}"/>
+                <a16:creationId xmlns:a16="http://schemas.microsoft.com/office/drawing/2014/main" id="{829C6586-B108-4C2B-8ABB-9D36581D9F36}"/>
               </a:ext>
             </a:extLst>
           </p:cNvPr>
@@ -3537,7 +3618,7 @@
           <p:cNvPr id="16" name="growth-formula">
             <a:extLst xmlns:a="http://schemas.openxmlformats.org/drawingml/2006/main">
               <a:ext uri="{FF2B5EF4-FFF2-40B4-BE49-F238E27FC236}">
-                <a16:creationId xmlns:a16="http://schemas.microsoft.com/office/drawing/2014/main" id="{26B59600-37A5-4E18-B9C8-610AAE3BA6DD}"/>
+                <a16:creationId xmlns:a16="http://schemas.microsoft.com/office/drawing/2014/main" id="{E3483CA9-A77A-4667-9A12-07927992E5DF}"/>
               </a:ext>
             </a:extLst>
           </p:cNvPr>
@@ -3595,7 +3676,7 @@
           <p:cNvPr id="17" name="growth-message">
             <a:extLst xmlns:a="http://schemas.openxmlformats.org/drawingml/2006/main">
               <a:ext uri="{FF2B5EF4-FFF2-40B4-BE49-F238E27FC236}">
-                <a16:creationId xmlns:a16="http://schemas.microsoft.com/office/drawing/2014/main" id="{15988C27-AB73-48B3-9277-5AA26248B201}"/>
+                <a16:creationId xmlns:a16="http://schemas.microsoft.com/office/drawing/2014/main" id="{DF7905E4-CBA7-456F-88E0-F84A8F5A959D}"/>
               </a:ext>
             </a:extLst>
           </p:cNvPr>
@@ -3653,7 +3734,7 @@
           <p:cNvPr id="18" name="tag-NP-zor problem ailesi">
             <a:extLst xmlns:a="http://schemas.openxmlformats.org/drawingml/2006/main">
               <a:ext uri="{FF2B5EF4-FFF2-40B4-BE49-F238E27FC236}">
-                <a16:creationId xmlns:a16="http://schemas.microsoft.com/office/drawing/2014/main" id="{51B6C64D-F110-4E47-8122-8693DD80521F}"/>
+                <a16:creationId xmlns:a16="http://schemas.microsoft.com/office/drawing/2014/main" id="{2FB00F70-8132-485F-A1D1-0FAC32DBDF25}"/>
               </a:ext>
             </a:extLst>
           </p:cNvPr>
@@ -3688,7 +3769,7 @@
           <p:cNvPr id="19" name="tag-text-NP-zor problem ailesi">
             <a:extLst xmlns:a="http://schemas.openxmlformats.org/drawingml/2006/main">
               <a:ext uri="{FF2B5EF4-FFF2-40B4-BE49-F238E27FC236}">
-                <a16:creationId xmlns:a16="http://schemas.microsoft.com/office/drawing/2014/main" id="{C36A82DD-AFAD-4521-9078-466B1021D361}"/>
+                <a16:creationId xmlns:a16="http://schemas.microsoft.com/office/drawing/2014/main" id="{C14683E4-4AEF-421D-AF33-C4EEFF53ADD4}"/>
               </a:ext>
             </a:extLst>
           </p:cNvPr>
@@ -3746,7 +3827,7 @@
           <p:cNvPr id="20" name="page-2">
             <a:extLst xmlns:a="http://schemas.openxmlformats.org/drawingml/2006/main">
               <a:ext uri="{FF2B5EF4-FFF2-40B4-BE49-F238E27FC236}">
-                <a16:creationId xmlns:a16="http://schemas.microsoft.com/office/drawing/2014/main" id="{069CA461-F102-4158-9F0E-488F527A2036}"/>
+                <a16:creationId xmlns:a16="http://schemas.microsoft.com/office/drawing/2014/main" id="{F07A3A72-6355-4DD6-BC07-F4A01A70F0B3}"/>
               </a:ext>
             </a:extLst>
           </p:cNvPr>
@@ -3802,7 +3883,7 @@
     </p:spTree>
     <p:extLst>
       <p:ext uri="{BB962C8B-B14F-4D97-AF65-F5344CB8AC3E}">
-        <p14:creationId xmlns:p14="http://schemas.microsoft.com/office/powerpoint/2010/main" val="1262054137"/>
+        <p14:creationId xmlns:p14="http://schemas.microsoft.com/office/powerpoint/2010/main" val="2066211894"/>
       </p:ext>
     </p:extLst>
   </p:cSld>
@@ -3833,7 +3914,7 @@
           <p:cNvPr id="29" name="Çözüm-eyebrow">
             <a:extLst xmlns:a="http://schemas.openxmlformats.org/drawingml/2006/main">
               <a:ext uri="{FF2B5EF4-FFF2-40B4-BE49-F238E27FC236}">
-                <a16:creationId xmlns:a16="http://schemas.microsoft.com/office/drawing/2014/main" id="{D8690B95-A03D-4F68-9180-533FBDEB6F9E}"/>
+                <a16:creationId xmlns:a16="http://schemas.microsoft.com/office/drawing/2014/main" id="{01A9287C-4EA9-42F3-B34E-E23677F302E7}"/>
               </a:ext>
             </a:extLst>
           </p:cNvPr>
@@ -3891,7 +3972,7 @@
           <p:cNvPr id="2" name="Çözüm-title">
             <a:extLst xmlns:a="http://schemas.openxmlformats.org/drawingml/2006/main">
               <a:ext uri="{FF2B5EF4-FFF2-40B4-BE49-F238E27FC236}">
-                <a16:creationId xmlns:a16="http://schemas.microsoft.com/office/drawing/2014/main" id="{7423435B-CD72-45E2-B291-F26B01C5B0BA}"/>
+                <a16:creationId xmlns:a16="http://schemas.microsoft.com/office/drawing/2014/main" id="{7B728230-5AD2-4F30-AC02-7BBA93C04C38}"/>
               </a:ext>
             </a:extLst>
           </p:cNvPr>
@@ -3949,7 +4030,7 @@
           <p:cNvPr id="3" name="Çözüm-subtitle">
             <a:extLst xmlns:a="http://schemas.openxmlformats.org/drawingml/2006/main">
               <a:ext uri="{FF2B5EF4-FFF2-40B4-BE49-F238E27FC236}">
-                <a16:creationId xmlns:a16="http://schemas.microsoft.com/office/drawing/2014/main" id="{F5BD28E4-D9A6-491A-94E3-ECBA7B2C560D}"/>
+                <a16:creationId xmlns:a16="http://schemas.microsoft.com/office/drawing/2014/main" id="{3259BFB1-9817-42FF-8DC9-C8D11BF19F1D}"/>
               </a:ext>
             </a:extLst>
           </p:cNvPr>
@@ -4007,7 +4088,7 @@
           <p:cNvPr id="4" name="flow-card-0">
             <a:extLst xmlns:a="http://schemas.openxmlformats.org/drawingml/2006/main">
               <a:ext uri="{FF2B5EF4-FFF2-40B4-BE49-F238E27FC236}">
-                <a16:creationId xmlns:a16="http://schemas.microsoft.com/office/drawing/2014/main" id="{DBFB3DCB-7C8D-4C0D-93D9-D2ECB8568933}"/>
+                <a16:creationId xmlns:a16="http://schemas.microsoft.com/office/drawing/2014/main" id="{DAE6B962-EE8E-4BB6-AA74-9AAE151C846E}"/>
               </a:ext>
             </a:extLst>
           </p:cNvPr>
@@ -4042,7 +4123,7 @@
           <p:cNvPr id="5" name="flow-no-bg-0">
             <a:extLst xmlns:a="http://schemas.openxmlformats.org/drawingml/2006/main">
               <a:ext uri="{FF2B5EF4-FFF2-40B4-BE49-F238E27FC236}">
-                <a16:creationId xmlns:a16="http://schemas.microsoft.com/office/drawing/2014/main" id="{E9D0AAC1-4620-44B5-849C-33882344CB3E}"/>
+                <a16:creationId xmlns:a16="http://schemas.microsoft.com/office/drawing/2014/main" id="{14A3F724-A77D-4085-BE8A-AA873554121F}"/>
               </a:ext>
             </a:extLst>
           </p:cNvPr>
@@ -4077,7 +4158,7 @@
           <p:cNvPr id="6" name="flow-no-0">
             <a:extLst xmlns:a="http://schemas.openxmlformats.org/drawingml/2006/main">
               <a:ext uri="{FF2B5EF4-FFF2-40B4-BE49-F238E27FC236}">
-                <a16:creationId xmlns:a16="http://schemas.microsoft.com/office/drawing/2014/main" id="{B071F808-D359-4DC3-8CD5-AFDE29495FA5}"/>
+                <a16:creationId xmlns:a16="http://schemas.microsoft.com/office/drawing/2014/main" id="{FC7C493F-EDED-4B62-8C96-FD7E0CFAA3D2}"/>
               </a:ext>
             </a:extLst>
           </p:cNvPr>
@@ -4135,7 +4216,7 @@
           <p:cNvPr id="7" name="flow-title-0">
             <a:extLst xmlns:a="http://schemas.openxmlformats.org/drawingml/2006/main">
               <a:ext uri="{FF2B5EF4-FFF2-40B4-BE49-F238E27FC236}">
-                <a16:creationId xmlns:a16="http://schemas.microsoft.com/office/drawing/2014/main" id="{4E2287DA-CFF4-402D-9416-7C3154988AD4}"/>
+                <a16:creationId xmlns:a16="http://schemas.microsoft.com/office/drawing/2014/main" id="{5EE6708F-6915-4104-981D-710548FA9D4D}"/>
               </a:ext>
             </a:extLst>
           </p:cNvPr>
@@ -4193,7 +4274,7 @@
           <p:cNvPr id="8" name="flow-body-0">
             <a:extLst xmlns:a="http://schemas.openxmlformats.org/drawingml/2006/main">
               <a:ext uri="{FF2B5EF4-FFF2-40B4-BE49-F238E27FC236}">
-                <a16:creationId xmlns:a16="http://schemas.microsoft.com/office/drawing/2014/main" id="{407CC017-A4A2-4AF3-9B8A-553220755EBD}"/>
+                <a16:creationId xmlns:a16="http://schemas.microsoft.com/office/drawing/2014/main" id="{97F7EE87-1A98-49FD-A2BE-D6A38F7A786B}"/>
               </a:ext>
             </a:extLst>
           </p:cNvPr>
@@ -4251,7 +4332,7 @@
           <p:cNvPr id="9" name="flow-card-1">
             <a:extLst xmlns:a="http://schemas.openxmlformats.org/drawingml/2006/main">
               <a:ext uri="{FF2B5EF4-FFF2-40B4-BE49-F238E27FC236}">
-                <a16:creationId xmlns:a16="http://schemas.microsoft.com/office/drawing/2014/main" id="{AFCF492C-374B-4100-82CA-4C0E1B12B3B2}"/>
+                <a16:creationId xmlns:a16="http://schemas.microsoft.com/office/drawing/2014/main" id="{DAAC7E16-BD59-48D7-986D-DC8227E14FDB}"/>
               </a:ext>
             </a:extLst>
           </p:cNvPr>
@@ -4286,7 +4367,7 @@
           <p:cNvPr id="10" name="flow-no-bg-1">
             <a:extLst xmlns:a="http://schemas.openxmlformats.org/drawingml/2006/main">
               <a:ext uri="{FF2B5EF4-FFF2-40B4-BE49-F238E27FC236}">
-                <a16:creationId xmlns:a16="http://schemas.microsoft.com/office/drawing/2014/main" id="{2B61F98F-9BCB-4610-86A4-6AE870E3A4FD}"/>
+                <a16:creationId xmlns:a16="http://schemas.microsoft.com/office/drawing/2014/main" id="{2930A375-557C-41A3-A49E-947784D65F27}"/>
               </a:ext>
             </a:extLst>
           </p:cNvPr>
@@ -4321,7 +4402,7 @@
           <p:cNvPr id="11" name="flow-no-1">
             <a:extLst xmlns:a="http://schemas.openxmlformats.org/drawingml/2006/main">
               <a:ext uri="{FF2B5EF4-FFF2-40B4-BE49-F238E27FC236}">
-                <a16:creationId xmlns:a16="http://schemas.microsoft.com/office/drawing/2014/main" id="{508129C2-7971-4532-9E29-793F2411883F}"/>
+                <a16:creationId xmlns:a16="http://schemas.microsoft.com/office/drawing/2014/main" id="{F463B92E-3D2F-4189-993C-D6CC334EE481}"/>
               </a:ext>
             </a:extLst>
           </p:cNvPr>
@@ -4379,7 +4460,7 @@
           <p:cNvPr id="12" name="flow-title-1">
             <a:extLst xmlns:a="http://schemas.openxmlformats.org/drawingml/2006/main">
               <a:ext uri="{FF2B5EF4-FFF2-40B4-BE49-F238E27FC236}">
-                <a16:creationId xmlns:a16="http://schemas.microsoft.com/office/drawing/2014/main" id="{31A05CA2-5CB0-4A81-B9CA-3412FA9EBE1C}"/>
+                <a16:creationId xmlns:a16="http://schemas.microsoft.com/office/drawing/2014/main" id="{B5D6515C-5361-4473-A135-4FBEA82CFFED}"/>
               </a:ext>
             </a:extLst>
           </p:cNvPr>
@@ -4437,7 +4518,7 @@
           <p:cNvPr id="13" name="flow-body-1">
             <a:extLst xmlns:a="http://schemas.openxmlformats.org/drawingml/2006/main">
               <a:ext uri="{FF2B5EF4-FFF2-40B4-BE49-F238E27FC236}">
-                <a16:creationId xmlns:a16="http://schemas.microsoft.com/office/drawing/2014/main" id="{D6A61218-B8CD-4E11-A017-211A626F175B}"/>
+                <a16:creationId xmlns:a16="http://schemas.microsoft.com/office/drawing/2014/main" id="{62F42143-360D-48BC-BE6F-F408ACBEB511}"/>
               </a:ext>
             </a:extLst>
           </p:cNvPr>
@@ -4495,7 +4576,7 @@
           <p:cNvPr id="14" name="flow-card-2">
             <a:extLst xmlns:a="http://schemas.openxmlformats.org/drawingml/2006/main">
               <a:ext uri="{FF2B5EF4-FFF2-40B4-BE49-F238E27FC236}">
-                <a16:creationId xmlns:a16="http://schemas.microsoft.com/office/drawing/2014/main" id="{6EFE713C-B353-4424-864D-20F41BE4F031}"/>
+                <a16:creationId xmlns:a16="http://schemas.microsoft.com/office/drawing/2014/main" id="{51A4E9DA-006C-411B-AF21-95332A156C1E}"/>
               </a:ext>
             </a:extLst>
           </p:cNvPr>
@@ -4530,7 +4611,7 @@
           <p:cNvPr id="15" name="flow-no-bg-2">
             <a:extLst xmlns:a="http://schemas.openxmlformats.org/drawingml/2006/main">
               <a:ext uri="{FF2B5EF4-FFF2-40B4-BE49-F238E27FC236}">
-                <a16:creationId xmlns:a16="http://schemas.microsoft.com/office/drawing/2014/main" id="{2221598E-2EE6-4E50-A23E-AD9344EA67F3}"/>
+                <a16:creationId xmlns:a16="http://schemas.microsoft.com/office/drawing/2014/main" id="{02F2749A-F631-4C5B-B2E8-A335A8D86B2F}"/>
               </a:ext>
             </a:extLst>
           </p:cNvPr>
@@ -4565,7 +4646,7 @@
           <p:cNvPr id="16" name="flow-no-2">
             <a:extLst xmlns:a="http://schemas.openxmlformats.org/drawingml/2006/main">
               <a:ext uri="{FF2B5EF4-FFF2-40B4-BE49-F238E27FC236}">
-                <a16:creationId xmlns:a16="http://schemas.microsoft.com/office/drawing/2014/main" id="{0718F287-6F49-4CEE-A022-143190A721EB}"/>
+                <a16:creationId xmlns:a16="http://schemas.microsoft.com/office/drawing/2014/main" id="{F9F95357-161A-49B8-A32F-7FCA5BCFADB3}"/>
               </a:ext>
             </a:extLst>
           </p:cNvPr>
@@ -4623,7 +4704,7 @@
           <p:cNvPr id="17" name="flow-title-2">
             <a:extLst xmlns:a="http://schemas.openxmlformats.org/drawingml/2006/main">
               <a:ext uri="{FF2B5EF4-FFF2-40B4-BE49-F238E27FC236}">
-                <a16:creationId xmlns:a16="http://schemas.microsoft.com/office/drawing/2014/main" id="{DA0EF188-54B5-4A04-83BE-83DDEB65CD47}"/>
+                <a16:creationId xmlns:a16="http://schemas.microsoft.com/office/drawing/2014/main" id="{3A70D862-6049-45FA-975D-C9D4B169F20F}"/>
               </a:ext>
             </a:extLst>
           </p:cNvPr>
@@ -4681,7 +4762,7 @@
           <p:cNvPr id="18" name="flow-body-2">
             <a:extLst xmlns:a="http://schemas.openxmlformats.org/drawingml/2006/main">
               <a:ext uri="{FF2B5EF4-FFF2-40B4-BE49-F238E27FC236}">
-                <a16:creationId xmlns:a16="http://schemas.microsoft.com/office/drawing/2014/main" id="{15EF3F8C-EA28-4D72-B636-355CD642A542}"/>
+                <a16:creationId xmlns:a16="http://schemas.microsoft.com/office/drawing/2014/main" id="{5E7D1B29-0EE2-4AB7-A53E-00937B6D8E7E}"/>
               </a:ext>
             </a:extLst>
           </p:cNvPr>
@@ -4739,7 +4820,7 @@
           <p:cNvPr id="19" name="flow-card-3">
             <a:extLst xmlns:a="http://schemas.openxmlformats.org/drawingml/2006/main">
               <a:ext uri="{FF2B5EF4-FFF2-40B4-BE49-F238E27FC236}">
-                <a16:creationId xmlns:a16="http://schemas.microsoft.com/office/drawing/2014/main" id="{D4F35E63-FBB5-4E18-965C-C3C077C114C4}"/>
+                <a16:creationId xmlns:a16="http://schemas.microsoft.com/office/drawing/2014/main" id="{4FD92BD3-EDCC-4A52-BB51-1C6F88191E4C}"/>
               </a:ext>
             </a:extLst>
           </p:cNvPr>
@@ -4774,7 +4855,7 @@
           <p:cNvPr id="20" name="flow-no-bg-3">
             <a:extLst xmlns:a="http://schemas.openxmlformats.org/drawingml/2006/main">
               <a:ext uri="{FF2B5EF4-FFF2-40B4-BE49-F238E27FC236}">
-                <a16:creationId xmlns:a16="http://schemas.microsoft.com/office/drawing/2014/main" id="{6A3550AD-3109-4486-AE3A-A118E451B333}"/>
+                <a16:creationId xmlns:a16="http://schemas.microsoft.com/office/drawing/2014/main" id="{96ED8E6D-4DEC-4DAA-9255-1417A3CFD3EA}"/>
               </a:ext>
             </a:extLst>
           </p:cNvPr>
@@ -4809,7 +4890,7 @@
           <p:cNvPr id="21" name="flow-no-3">
             <a:extLst xmlns:a="http://schemas.openxmlformats.org/drawingml/2006/main">
               <a:ext uri="{FF2B5EF4-FFF2-40B4-BE49-F238E27FC236}">
-                <a16:creationId xmlns:a16="http://schemas.microsoft.com/office/drawing/2014/main" id="{06D72BB7-740D-4D4F-B456-DACE4B437C08}"/>
+                <a16:creationId xmlns:a16="http://schemas.microsoft.com/office/drawing/2014/main" id="{015057E0-03FE-4A8B-9555-FC4C0507AC6F}"/>
               </a:ext>
             </a:extLst>
           </p:cNvPr>
@@ -4867,7 +4948,7 @@
           <p:cNvPr id="22" name="flow-title-3">
             <a:extLst xmlns:a="http://schemas.openxmlformats.org/drawingml/2006/main">
               <a:ext uri="{FF2B5EF4-FFF2-40B4-BE49-F238E27FC236}">
-                <a16:creationId xmlns:a16="http://schemas.microsoft.com/office/drawing/2014/main" id="{3419C0F1-61D2-4E79-96F9-7411BEAD0B6A}"/>
+                <a16:creationId xmlns:a16="http://schemas.microsoft.com/office/drawing/2014/main" id="{D63EA935-7956-4085-AE70-DACBE0EE53B6}"/>
               </a:ext>
             </a:extLst>
           </p:cNvPr>
@@ -4925,7 +5006,7 @@
           <p:cNvPr id="23" name="flow-body-3">
             <a:extLst xmlns:a="http://schemas.openxmlformats.org/drawingml/2006/main">
               <a:ext uri="{FF2B5EF4-FFF2-40B4-BE49-F238E27FC236}">
-                <a16:creationId xmlns:a16="http://schemas.microsoft.com/office/drawing/2014/main" id="{61226671-6D94-4641-B071-DD4A14013D35}"/>
+                <a16:creationId xmlns:a16="http://schemas.microsoft.com/office/drawing/2014/main" id="{7DB58213-BB8C-426E-A116-1B99058F83A2}"/>
               </a:ext>
             </a:extLst>
           </p:cNvPr>
@@ -5061,7 +5142,7 @@
           <p:cNvPr id="27" name="flow-takeaway">
             <a:extLst xmlns:a="http://schemas.openxmlformats.org/drawingml/2006/main">
               <a:ext uri="{FF2B5EF4-FFF2-40B4-BE49-F238E27FC236}">
-                <a16:creationId xmlns:a16="http://schemas.microsoft.com/office/drawing/2014/main" id="{4D6A3965-DEB2-4BAA-ACED-2703E7C875E2}"/>
+                <a16:creationId xmlns:a16="http://schemas.microsoft.com/office/drawing/2014/main" id="{BADE1F71-2565-4EB4-A225-FE9DC1780B11}"/>
               </a:ext>
             </a:extLst>
           </p:cNvPr>
@@ -5119,7 +5200,7 @@
           <p:cNvPr id="28" name="page-3">
             <a:extLst xmlns:a="http://schemas.openxmlformats.org/drawingml/2006/main">
               <a:ext uri="{FF2B5EF4-FFF2-40B4-BE49-F238E27FC236}">
-                <a16:creationId xmlns:a16="http://schemas.microsoft.com/office/drawing/2014/main" id="{BBFE6958-6E4B-490F-BE09-E236D0B480D5}"/>
+                <a16:creationId xmlns:a16="http://schemas.microsoft.com/office/drawing/2014/main" id="{2FEB51D7-8F45-405C-B044-C79F14364C2D}"/>
               </a:ext>
             </a:extLst>
           </p:cNvPr>
@@ -5175,7 +5256,7 @@
     </p:spTree>
     <p:extLst>
       <p:ext uri="{BB962C8B-B14F-4D97-AF65-F5344CB8AC3E}">
-        <p14:creationId xmlns:p14="http://schemas.microsoft.com/office/powerpoint/2010/main" val="433481315"/>
+        <p14:creationId xmlns:p14="http://schemas.microsoft.com/office/powerpoint/2010/main" val="9348121"/>
       </p:ext>
     </p:extLst>
   </p:cSld>
@@ -5206,7 +5287,7 @@
           <p:cNvPr id="10" name="Canlı demo-eyebrow">
             <a:extLst xmlns:a="http://schemas.openxmlformats.org/drawingml/2006/main">
               <a:ext uri="{FF2B5EF4-FFF2-40B4-BE49-F238E27FC236}">
-                <a16:creationId xmlns:a16="http://schemas.microsoft.com/office/drawing/2014/main" id="{03CA8BC9-D3CF-4B64-8616-E98863C5CEBD}"/>
+                <a16:creationId xmlns:a16="http://schemas.microsoft.com/office/drawing/2014/main" id="{8FAD56A4-09B0-4269-8A70-46CE3ADB62D2}"/>
               </a:ext>
             </a:extLst>
           </p:cNvPr>
@@ -5264,7 +5345,7 @@
           <p:cNvPr id="2" name="Canlı demo-title">
             <a:extLst xmlns:a="http://schemas.openxmlformats.org/drawingml/2006/main">
               <a:ext uri="{FF2B5EF4-FFF2-40B4-BE49-F238E27FC236}">
-                <a16:creationId xmlns:a16="http://schemas.microsoft.com/office/drawing/2014/main" id="{0EE3F7AB-1068-43D4-A3D7-F6D5A3C0DB02}"/>
+                <a16:creationId xmlns:a16="http://schemas.microsoft.com/office/drawing/2014/main" id="{2EA728AD-BF4C-4E04-9F8C-15179FDDE830}"/>
               </a:ext>
             </a:extLst>
           </p:cNvPr>
@@ -5322,7 +5403,7 @@
           <p:cNvPr id="3" name="demo-copy-card">
             <a:extLst xmlns:a="http://schemas.openxmlformats.org/drawingml/2006/main">
               <a:ext uri="{FF2B5EF4-FFF2-40B4-BE49-F238E27FC236}">
-                <a16:creationId xmlns:a16="http://schemas.microsoft.com/office/drawing/2014/main" id="{D248853A-A86C-496E-8365-BCC7DB35CBEA}"/>
+                <a16:creationId xmlns:a16="http://schemas.microsoft.com/office/drawing/2014/main" id="{5E69A867-5555-4829-A583-4EF2FEE8AC77}"/>
               </a:ext>
             </a:extLst>
           </p:cNvPr>
@@ -5357,7 +5438,7 @@
           <p:cNvPr id="4" name="demo-copy-kicker">
             <a:extLst xmlns:a="http://schemas.openxmlformats.org/drawingml/2006/main">
               <a:ext uri="{FF2B5EF4-FFF2-40B4-BE49-F238E27FC236}">
-                <a16:creationId xmlns:a16="http://schemas.microsoft.com/office/drawing/2014/main" id="{C8D063AC-C1EF-43CE-9B97-A0C43785F7C5}"/>
+                <a16:creationId xmlns:a16="http://schemas.microsoft.com/office/drawing/2014/main" id="{272176BF-135D-45BB-88EB-414543488CD7}"/>
               </a:ext>
             </a:extLst>
           </p:cNvPr>
@@ -5415,7 +5496,7 @@
           <p:cNvPr id="5" name="demo-copy">
             <a:extLst xmlns:a="http://schemas.openxmlformats.org/drawingml/2006/main">
               <a:ext uri="{FF2B5EF4-FFF2-40B4-BE49-F238E27FC236}">
-                <a16:creationId xmlns:a16="http://schemas.microsoft.com/office/drawing/2014/main" id="{3EEAA840-7ED5-4BBC-BB4D-918A21B0B7FA}"/>
+                <a16:creationId xmlns:a16="http://schemas.microsoft.com/office/drawing/2014/main" id="{3A3B8F90-8942-4F81-B083-CE1895E7CDE5}"/>
               </a:ext>
             </a:extLst>
           </p:cNvPr>
@@ -5473,7 +5554,7 @@
           <p:cNvPr id="6" name="demo-three-steps">
             <a:extLst xmlns:a="http://schemas.openxmlformats.org/drawingml/2006/main">
               <a:ext uri="{FF2B5EF4-FFF2-40B4-BE49-F238E27FC236}">
-                <a16:creationId xmlns:a16="http://schemas.microsoft.com/office/drawing/2014/main" id="{ACB90FA9-F6DF-4761-976A-B25E924A0A9B}"/>
+                <a16:creationId xmlns:a16="http://schemas.microsoft.com/office/drawing/2014/main" id="{9DC023C7-AD18-4F2E-8D7B-BC07BBCAE6E4}"/>
               </a:ext>
             </a:extLst>
           </p:cNvPr>
@@ -5577,7 +5658,7 @@
           <p:cNvPr id="7" name="demo-image-frame">
             <a:extLst xmlns:a="http://schemas.openxmlformats.org/drawingml/2006/main">
               <a:ext uri="{FF2B5EF4-FFF2-40B4-BE49-F238E27FC236}">
-                <a16:creationId xmlns:a16="http://schemas.microsoft.com/office/drawing/2014/main" id="{8C8AA2D5-98B0-4195-A5E4-2561A0D2F820}"/>
+                <a16:creationId xmlns:a16="http://schemas.microsoft.com/office/drawing/2014/main" id="{51D4C834-5791-471F-AD12-F69C3EF283CD}"/>
               </a:ext>
             </a:extLst>
           </p:cNvPr>
@@ -5616,7 +5697,7 @@
           <p:nvPr/>
         </p:nvPicPr>
         <p:blipFill>
-          <a:blip xmlns:r="http://schemas.openxmlformats.org/officeDocument/2006/relationships" xmlns:a="http://schemas.openxmlformats.org/drawingml/2006/main" r:embed="R0459aa71f86c4809"/>
+          <a:blip xmlns:r="http://schemas.openxmlformats.org/officeDocument/2006/relationships" xmlns:a="http://schemas.openxmlformats.org/drawingml/2006/main" r:embed="Rd887b1f583054eef"/>
           <a:stretch xmlns:a="http://schemas.openxmlformats.org/drawingml/2006/main"/>
         </p:blipFill>
         <p:spPr>
@@ -5636,7 +5717,7 @@
           <p:cNvPr id="9" name="page-4">
             <a:extLst xmlns:a="http://schemas.openxmlformats.org/drawingml/2006/main">
               <a:ext uri="{FF2B5EF4-FFF2-40B4-BE49-F238E27FC236}">
-                <a16:creationId xmlns:a16="http://schemas.microsoft.com/office/drawing/2014/main" id="{DB82DD26-C45B-44D0-8D05-E1633A16399E}"/>
+                <a16:creationId xmlns:a16="http://schemas.microsoft.com/office/drawing/2014/main" id="{AD1F1F7B-B021-4602-9366-90E7CA80B1D6}"/>
               </a:ext>
             </a:extLst>
           </p:cNvPr>
@@ -5692,7 +5773,7 @@
     </p:spTree>
     <p:extLst>
       <p:ext uri="{BB962C8B-B14F-4D97-AF65-F5344CB8AC3E}">
-        <p14:creationId xmlns:p14="http://schemas.microsoft.com/office/powerpoint/2010/main" val="637909225"/>
+        <p14:creationId xmlns:p14="http://schemas.microsoft.com/office/powerpoint/2010/main" val="1676769583"/>
       </p:ext>
     </p:extLst>
   </p:cSld>
@@ -5723,7 +5804,7 @@
           <p:cNvPr id="28" name="q-eyebrow">
             <a:extLst xmlns:a="http://schemas.openxmlformats.org/drawingml/2006/main">
               <a:ext uri="{FF2B5EF4-FFF2-40B4-BE49-F238E27FC236}">
-                <a16:creationId xmlns:a16="http://schemas.microsoft.com/office/drawing/2014/main" id="{02BE45D9-64C8-42B6-8C38-90906511197C}"/>
+                <a16:creationId xmlns:a16="http://schemas.microsoft.com/office/drawing/2014/main" id="{18536822-D4B3-4730-9C30-DEB8BBF81D1E}"/>
               </a:ext>
             </a:extLst>
           </p:cNvPr>
@@ -5781,7 +5862,7 @@
           <p:cNvPr id="2" name="q-title">
             <a:extLst xmlns:a="http://schemas.openxmlformats.org/drawingml/2006/main">
               <a:ext uri="{FF2B5EF4-FFF2-40B4-BE49-F238E27FC236}">
-                <a16:creationId xmlns:a16="http://schemas.microsoft.com/office/drawing/2014/main" id="{E1567F21-6FC6-4665-BB4E-344CE31A0FBC}"/>
+                <a16:creationId xmlns:a16="http://schemas.microsoft.com/office/drawing/2014/main" id="{C36475D4-9555-4A28-A18D-940C1F038821}"/>
               </a:ext>
             </a:extLst>
           </p:cNvPr>
@@ -5839,7 +5920,7 @@
           <p:cNvPr id="3" name="q-card-0">
             <a:extLst xmlns:a="http://schemas.openxmlformats.org/drawingml/2006/main">
               <a:ext uri="{FF2B5EF4-FFF2-40B4-BE49-F238E27FC236}">
-                <a16:creationId xmlns:a16="http://schemas.microsoft.com/office/drawing/2014/main" id="{F13F44D7-A544-4A22-856A-1BF54C473695}"/>
+                <a16:creationId xmlns:a16="http://schemas.microsoft.com/office/drawing/2014/main" id="{6BAEF9FB-DBA4-41E6-9010-91D7370AD2EC}"/>
               </a:ext>
             </a:extLst>
           </p:cNvPr>
@@ -5874,7 +5955,7 @@
           <p:cNvPr id="4" name="gate-bg-0">
             <a:extLst xmlns:a="http://schemas.openxmlformats.org/drawingml/2006/main">
               <a:ext uri="{FF2B5EF4-FFF2-40B4-BE49-F238E27FC236}">
-                <a16:creationId xmlns:a16="http://schemas.microsoft.com/office/drawing/2014/main" id="{BE54E1EF-BE22-4249-A792-C01FC3E8A726}"/>
+                <a16:creationId xmlns:a16="http://schemas.microsoft.com/office/drawing/2014/main" id="{20E9EE63-C1AD-4076-A67F-0C279CB58D01}"/>
               </a:ext>
             </a:extLst>
           </p:cNvPr>
@@ -5909,7 +5990,7 @@
           <p:cNvPr id="5" name="gate-0">
             <a:extLst xmlns:a="http://schemas.openxmlformats.org/drawingml/2006/main">
               <a:ext uri="{FF2B5EF4-FFF2-40B4-BE49-F238E27FC236}">
-                <a16:creationId xmlns:a16="http://schemas.microsoft.com/office/drawing/2014/main" id="{E868D18D-FC78-49B1-B47E-6612A7D0045E}"/>
+                <a16:creationId xmlns:a16="http://schemas.microsoft.com/office/drawing/2014/main" id="{82BFD283-BDB1-456D-BDCE-3B4F4FEFD366}"/>
               </a:ext>
             </a:extLst>
           </p:cNvPr>
@@ -5967,7 +6048,7 @@
           <p:cNvPr id="6" name="q-title-0">
             <a:extLst xmlns:a="http://schemas.openxmlformats.org/drawingml/2006/main">
               <a:ext uri="{FF2B5EF4-FFF2-40B4-BE49-F238E27FC236}">
-                <a16:creationId xmlns:a16="http://schemas.microsoft.com/office/drawing/2014/main" id="{49DFE955-2E93-454F-BBA2-7B77FCD5D1D4}"/>
+                <a16:creationId xmlns:a16="http://schemas.microsoft.com/office/drawing/2014/main" id="{D2BA08C1-F79B-4FF3-A8AD-29D948A2A6B3}"/>
               </a:ext>
             </a:extLst>
           </p:cNvPr>
@@ -6025,7 +6106,7 @@
           <p:cNvPr id="7" name="q-body-0">
             <a:extLst xmlns:a="http://schemas.openxmlformats.org/drawingml/2006/main">
               <a:ext uri="{FF2B5EF4-FFF2-40B4-BE49-F238E27FC236}">
-                <a16:creationId xmlns:a16="http://schemas.microsoft.com/office/drawing/2014/main" id="{A9C27BE0-93AD-4C8B-A65A-41882E17BB1A}"/>
+                <a16:creationId xmlns:a16="http://schemas.microsoft.com/office/drawing/2014/main" id="{2A21B346-D205-4416-84B0-5AE49960CA2B}"/>
               </a:ext>
             </a:extLst>
           </p:cNvPr>
@@ -6083,7 +6164,7 @@
           <p:cNvPr id="8" name="q-card-1">
             <a:extLst xmlns:a="http://schemas.openxmlformats.org/drawingml/2006/main">
               <a:ext uri="{FF2B5EF4-FFF2-40B4-BE49-F238E27FC236}">
-                <a16:creationId xmlns:a16="http://schemas.microsoft.com/office/drawing/2014/main" id="{8DF5AE53-70B5-4D72-B572-62FA09B8FA31}"/>
+                <a16:creationId xmlns:a16="http://schemas.microsoft.com/office/drawing/2014/main" id="{80F0E1A9-2495-47AD-B784-E22C5107A15F}"/>
               </a:ext>
             </a:extLst>
           </p:cNvPr>
@@ -6118,7 +6199,7 @@
           <p:cNvPr id="9" name="gate-bg-1">
             <a:extLst xmlns:a="http://schemas.openxmlformats.org/drawingml/2006/main">
               <a:ext uri="{FF2B5EF4-FFF2-40B4-BE49-F238E27FC236}">
-                <a16:creationId xmlns:a16="http://schemas.microsoft.com/office/drawing/2014/main" id="{84F8231D-B9B1-46E1-8CC1-8286696E9284}"/>
+                <a16:creationId xmlns:a16="http://schemas.microsoft.com/office/drawing/2014/main" id="{5EDC99B3-87D7-435E-9BFE-61A4BE90DC67}"/>
               </a:ext>
             </a:extLst>
           </p:cNvPr>
@@ -6153,7 +6234,7 @@
           <p:cNvPr id="10" name="gate-1">
             <a:extLst xmlns:a="http://schemas.openxmlformats.org/drawingml/2006/main">
               <a:ext uri="{FF2B5EF4-FFF2-40B4-BE49-F238E27FC236}">
-                <a16:creationId xmlns:a16="http://schemas.microsoft.com/office/drawing/2014/main" id="{6F8D8587-8FA4-4223-AA44-6CB995F1FFD7}"/>
+                <a16:creationId xmlns:a16="http://schemas.microsoft.com/office/drawing/2014/main" id="{CF50AAFB-D627-4C51-9377-329261EA1FDD}"/>
               </a:ext>
             </a:extLst>
           </p:cNvPr>
@@ -6211,7 +6292,7 @@
           <p:cNvPr id="11" name="q-title-1">
             <a:extLst xmlns:a="http://schemas.openxmlformats.org/drawingml/2006/main">
               <a:ext uri="{FF2B5EF4-FFF2-40B4-BE49-F238E27FC236}">
-                <a16:creationId xmlns:a16="http://schemas.microsoft.com/office/drawing/2014/main" id="{741B9D19-583B-4AF0-8022-E9521954F689}"/>
+                <a16:creationId xmlns:a16="http://schemas.microsoft.com/office/drawing/2014/main" id="{C3B2CF48-100B-4D73-85B0-0653AEFAC973}"/>
               </a:ext>
             </a:extLst>
           </p:cNvPr>
@@ -6269,7 +6350,7 @@
           <p:cNvPr id="12" name="q-body-1">
             <a:extLst xmlns:a="http://schemas.openxmlformats.org/drawingml/2006/main">
               <a:ext uri="{FF2B5EF4-FFF2-40B4-BE49-F238E27FC236}">
-                <a16:creationId xmlns:a16="http://schemas.microsoft.com/office/drawing/2014/main" id="{DB73014F-33F3-422B-B31A-B8FBBEBAED80}"/>
+                <a16:creationId xmlns:a16="http://schemas.microsoft.com/office/drawing/2014/main" id="{3A94CC3F-9C21-4A71-9A9A-D0798CEDFEC8}"/>
               </a:ext>
             </a:extLst>
           </p:cNvPr>
@@ -6327,7 +6408,7 @@
           <p:cNvPr id="13" name="q-card-2">
             <a:extLst xmlns:a="http://schemas.openxmlformats.org/drawingml/2006/main">
               <a:ext uri="{FF2B5EF4-FFF2-40B4-BE49-F238E27FC236}">
-                <a16:creationId xmlns:a16="http://schemas.microsoft.com/office/drawing/2014/main" id="{C762F4BF-832E-46F3-BAA9-19DFE123A92D}"/>
+                <a16:creationId xmlns:a16="http://schemas.microsoft.com/office/drawing/2014/main" id="{8A133541-B32C-473A-9200-CE804145291E}"/>
               </a:ext>
             </a:extLst>
           </p:cNvPr>
@@ -6362,7 +6443,7 @@
           <p:cNvPr id="14" name="gate-bg-2">
             <a:extLst xmlns:a="http://schemas.openxmlformats.org/drawingml/2006/main">
               <a:ext uri="{FF2B5EF4-FFF2-40B4-BE49-F238E27FC236}">
-                <a16:creationId xmlns:a16="http://schemas.microsoft.com/office/drawing/2014/main" id="{1809B113-4281-4B79-9C30-BB9E7E0D50E8}"/>
+                <a16:creationId xmlns:a16="http://schemas.microsoft.com/office/drawing/2014/main" id="{25C9A416-38DF-4F1E-9123-EF5C4928C03D}"/>
               </a:ext>
             </a:extLst>
           </p:cNvPr>
@@ -6397,7 +6478,7 @@
           <p:cNvPr id="15" name="gate-2">
             <a:extLst xmlns:a="http://schemas.openxmlformats.org/drawingml/2006/main">
               <a:ext uri="{FF2B5EF4-FFF2-40B4-BE49-F238E27FC236}">
-                <a16:creationId xmlns:a16="http://schemas.microsoft.com/office/drawing/2014/main" id="{39EE4CEB-EC78-4C33-BA58-2DF7360D4845}"/>
+                <a16:creationId xmlns:a16="http://schemas.microsoft.com/office/drawing/2014/main" id="{0FAAD37F-0EAD-4068-8FF6-A23FA4FEEBC0}"/>
               </a:ext>
             </a:extLst>
           </p:cNvPr>
@@ -6455,7 +6536,7 @@
           <p:cNvPr id="16" name="q-title-2">
             <a:extLst xmlns:a="http://schemas.openxmlformats.org/drawingml/2006/main">
               <a:ext uri="{FF2B5EF4-FFF2-40B4-BE49-F238E27FC236}">
-                <a16:creationId xmlns:a16="http://schemas.microsoft.com/office/drawing/2014/main" id="{BD0E3AEE-47E5-424D-9E75-BCEBEFDC98C0}"/>
+                <a16:creationId xmlns:a16="http://schemas.microsoft.com/office/drawing/2014/main" id="{A6AEEA79-E9D5-4CEF-B343-686AE7EDAD99}"/>
               </a:ext>
             </a:extLst>
           </p:cNvPr>
@@ -6513,7 +6594,7 @@
           <p:cNvPr id="17" name="q-body-2">
             <a:extLst xmlns:a="http://schemas.openxmlformats.org/drawingml/2006/main">
               <a:ext uri="{FF2B5EF4-FFF2-40B4-BE49-F238E27FC236}">
-                <a16:creationId xmlns:a16="http://schemas.microsoft.com/office/drawing/2014/main" id="{68252371-C0F5-4662-AAA9-3DEB260FAB23}"/>
+                <a16:creationId xmlns:a16="http://schemas.microsoft.com/office/drawing/2014/main" id="{52248D5F-5622-4A1A-9162-F127F7134C6D}"/>
               </a:ext>
             </a:extLst>
           </p:cNvPr>
@@ -6571,7 +6652,7 @@
           <p:cNvPr id="18" name="q-card-3">
             <a:extLst xmlns:a="http://schemas.openxmlformats.org/drawingml/2006/main">
               <a:ext uri="{FF2B5EF4-FFF2-40B4-BE49-F238E27FC236}">
-                <a16:creationId xmlns:a16="http://schemas.microsoft.com/office/drawing/2014/main" id="{100D4BEB-C169-40B1-81AB-D0A4A30A2172}"/>
+                <a16:creationId xmlns:a16="http://schemas.microsoft.com/office/drawing/2014/main" id="{A5B2BD07-C7D4-45E0-9B20-55848F150562}"/>
               </a:ext>
             </a:extLst>
           </p:cNvPr>
@@ -6606,7 +6687,7 @@
           <p:cNvPr id="19" name="gate-bg-3">
             <a:extLst xmlns:a="http://schemas.openxmlformats.org/drawingml/2006/main">
               <a:ext uri="{FF2B5EF4-FFF2-40B4-BE49-F238E27FC236}">
-                <a16:creationId xmlns:a16="http://schemas.microsoft.com/office/drawing/2014/main" id="{E60E6978-A5E4-4553-AC5F-C9A7D9B67B16}"/>
+                <a16:creationId xmlns:a16="http://schemas.microsoft.com/office/drawing/2014/main" id="{8673EF59-618A-430E-9EA3-0BA272E23984}"/>
               </a:ext>
             </a:extLst>
           </p:cNvPr>
@@ -6641,7 +6722,7 @@
           <p:cNvPr id="20" name="gate-3">
             <a:extLst xmlns:a="http://schemas.openxmlformats.org/drawingml/2006/main">
               <a:ext uri="{FF2B5EF4-FFF2-40B4-BE49-F238E27FC236}">
-                <a16:creationId xmlns:a16="http://schemas.microsoft.com/office/drawing/2014/main" id="{D685CE62-005B-4E76-BC02-C7C79CD1EE4D}"/>
+                <a16:creationId xmlns:a16="http://schemas.microsoft.com/office/drawing/2014/main" id="{6692ADFC-E5E7-4D99-95C3-D457C300256E}"/>
               </a:ext>
             </a:extLst>
           </p:cNvPr>
@@ -6699,7 +6780,7 @@
           <p:cNvPr id="21" name="q-title-3">
             <a:extLst xmlns:a="http://schemas.openxmlformats.org/drawingml/2006/main">
               <a:ext uri="{FF2B5EF4-FFF2-40B4-BE49-F238E27FC236}">
-                <a16:creationId xmlns:a16="http://schemas.microsoft.com/office/drawing/2014/main" id="{ADD6F109-0063-4D01-8111-F022C935C852}"/>
+                <a16:creationId xmlns:a16="http://schemas.microsoft.com/office/drawing/2014/main" id="{39FF4242-02C9-46F9-B9F5-134CC59BF747}"/>
               </a:ext>
             </a:extLst>
           </p:cNvPr>
@@ -6757,7 +6838,7 @@
           <p:cNvPr id="22" name="q-body-3">
             <a:extLst xmlns:a="http://schemas.openxmlformats.org/drawingml/2006/main">
               <a:ext uri="{FF2B5EF4-FFF2-40B4-BE49-F238E27FC236}">
-                <a16:creationId xmlns:a16="http://schemas.microsoft.com/office/drawing/2014/main" id="{5196C7A4-D3CD-4E3E-A5C8-7862D52A4268}"/>
+                <a16:creationId xmlns:a16="http://schemas.microsoft.com/office/drawing/2014/main" id="{FD7CCE0A-D25E-4780-95A6-87BFDD4D15BB}"/>
               </a:ext>
             </a:extLst>
           </p:cNvPr>
@@ -6893,7 +6974,7 @@
           <p:cNvPr id="26" name="q-truth">
             <a:extLst xmlns:a="http://schemas.openxmlformats.org/drawingml/2006/main">
               <a:ext uri="{FF2B5EF4-FFF2-40B4-BE49-F238E27FC236}">
-                <a16:creationId xmlns:a16="http://schemas.microsoft.com/office/drawing/2014/main" id="{0FE633F5-0494-4538-8357-FC7A46E7D5AE}"/>
+                <a16:creationId xmlns:a16="http://schemas.microsoft.com/office/drawing/2014/main" id="{64E0CA24-F66E-448F-8000-FB6559057332}"/>
               </a:ext>
             </a:extLst>
           </p:cNvPr>
@@ -6951,7 +7032,7 @@
           <p:cNvPr id="27" name="page-5">
             <a:extLst xmlns:a="http://schemas.openxmlformats.org/drawingml/2006/main">
               <a:ext uri="{FF2B5EF4-FFF2-40B4-BE49-F238E27FC236}">
-                <a16:creationId xmlns:a16="http://schemas.microsoft.com/office/drawing/2014/main" id="{96E013C1-8E37-4515-A644-A73FC7C3DD7F}"/>
+                <a16:creationId xmlns:a16="http://schemas.microsoft.com/office/drawing/2014/main" id="{CE36D9E9-24FD-49E6-9D54-D64364662105}"/>
               </a:ext>
             </a:extLst>
           </p:cNvPr>
@@ -7007,7 +7088,7 @@
     </p:spTree>
     <p:extLst>
       <p:ext uri="{BB962C8B-B14F-4D97-AF65-F5344CB8AC3E}">
-        <p14:creationId xmlns:p14="http://schemas.microsoft.com/office/powerpoint/2010/main" val="1273017319"/>
+        <p14:creationId xmlns:p14="http://schemas.microsoft.com/office/powerpoint/2010/main" val="893479596"/>
       </p:ext>
     </p:extLst>
   </p:cSld>
@@ -7038,7 +7119,7 @@
           <p:cNvPr id="22" name="Kanıt-eyebrow">
             <a:extLst xmlns:a="http://schemas.openxmlformats.org/drawingml/2006/main">
               <a:ext uri="{FF2B5EF4-FFF2-40B4-BE49-F238E27FC236}">
-                <a16:creationId xmlns:a16="http://schemas.microsoft.com/office/drawing/2014/main" id="{AE4232C8-03EB-4111-922C-C7F89B08D5B6}"/>
+                <a16:creationId xmlns:a16="http://schemas.microsoft.com/office/drawing/2014/main" id="{F70E10E6-06A9-4146-887C-43FB24B4C5E7}"/>
               </a:ext>
             </a:extLst>
           </p:cNvPr>
@@ -7096,7 +7177,7 @@
           <p:cNvPr id="2" name="Kanıt-title">
             <a:extLst xmlns:a="http://schemas.openxmlformats.org/drawingml/2006/main">
               <a:ext uri="{FF2B5EF4-FFF2-40B4-BE49-F238E27FC236}">
-                <a16:creationId xmlns:a16="http://schemas.microsoft.com/office/drawing/2014/main" id="{3F04E567-1423-404E-A8E9-9AD2FA06BD26}"/>
+                <a16:creationId xmlns:a16="http://schemas.microsoft.com/office/drawing/2014/main" id="{DC72E7A9-AF88-4159-9196-190F9FE47972}"/>
               </a:ext>
             </a:extLst>
           </p:cNvPr>
@@ -7154,7 +7235,7 @@
           <p:cNvPr id="3" name="Kanıt-subtitle">
             <a:extLst xmlns:a="http://schemas.openxmlformats.org/drawingml/2006/main">
               <a:ext uri="{FF2B5EF4-FFF2-40B4-BE49-F238E27FC236}">
-                <a16:creationId xmlns:a16="http://schemas.microsoft.com/office/drawing/2014/main" id="{BB8F2B60-98BB-460B-8E6B-8107287481FC}"/>
+                <a16:creationId xmlns:a16="http://schemas.microsoft.com/office/drawing/2014/main" id="{105AE8D7-1131-49E7-8907-4CBF8B23C8CA}"/>
               </a:ext>
             </a:extLst>
           </p:cNvPr>
@@ -7212,7 +7293,7 @@
           <p:cNvPr id="4" name="level-0">
             <a:extLst xmlns:a="http://schemas.openxmlformats.org/drawingml/2006/main">
               <a:ext uri="{FF2B5EF4-FFF2-40B4-BE49-F238E27FC236}">
-                <a16:creationId xmlns:a16="http://schemas.microsoft.com/office/drawing/2014/main" id="{F901E0A2-8FF6-48E0-845D-B3224A22390C}"/>
+                <a16:creationId xmlns:a16="http://schemas.microsoft.com/office/drawing/2014/main" id="{1F447251-D491-4A53-9EBF-DDB5F5CAB375}"/>
               </a:ext>
             </a:extLst>
           </p:cNvPr>
@@ -7247,7 +7328,7 @@
           <p:cNvPr id="5" name="level-n-bg-0">
             <a:extLst xmlns:a="http://schemas.openxmlformats.org/drawingml/2006/main">
               <a:ext uri="{FF2B5EF4-FFF2-40B4-BE49-F238E27FC236}">
-                <a16:creationId xmlns:a16="http://schemas.microsoft.com/office/drawing/2014/main" id="{941FB059-44A9-480E-B56C-7C2C124EC617}"/>
+                <a16:creationId xmlns:a16="http://schemas.microsoft.com/office/drawing/2014/main" id="{75A0358A-5481-4145-B302-738C3F145000}"/>
               </a:ext>
             </a:extLst>
           </p:cNvPr>
@@ -7282,7 +7363,7 @@
           <p:cNvPr id="6" name="level-n-0">
             <a:extLst xmlns:a="http://schemas.openxmlformats.org/drawingml/2006/main">
               <a:ext uri="{FF2B5EF4-FFF2-40B4-BE49-F238E27FC236}">
-                <a16:creationId xmlns:a16="http://schemas.microsoft.com/office/drawing/2014/main" id="{E3237137-5184-463B-A590-4FBC3639F573}"/>
+                <a16:creationId xmlns:a16="http://schemas.microsoft.com/office/drawing/2014/main" id="{1A4744DD-3483-4CA0-9FEE-CC87CF4A7804}"/>
               </a:ext>
             </a:extLst>
           </p:cNvPr>
@@ -7340,7 +7421,7 @@
           <p:cNvPr id="7" name="level-title-0">
             <a:extLst xmlns:a="http://schemas.openxmlformats.org/drawingml/2006/main">
               <a:ext uri="{FF2B5EF4-FFF2-40B4-BE49-F238E27FC236}">
-                <a16:creationId xmlns:a16="http://schemas.microsoft.com/office/drawing/2014/main" id="{6BA3DC3F-97EE-47BC-806B-2578B1CB4A75}"/>
+                <a16:creationId xmlns:a16="http://schemas.microsoft.com/office/drawing/2014/main" id="{E96881C3-5511-4022-B7AF-4837EBC6FC77}"/>
               </a:ext>
             </a:extLst>
           </p:cNvPr>
@@ -7398,7 +7479,7 @@
           <p:cNvPr id="8" name="level-body-0">
             <a:extLst xmlns:a="http://schemas.openxmlformats.org/drawingml/2006/main">
               <a:ext uri="{FF2B5EF4-FFF2-40B4-BE49-F238E27FC236}">
-                <a16:creationId xmlns:a16="http://schemas.microsoft.com/office/drawing/2014/main" id="{CA5409F1-6FF4-4008-AC3D-B5F7E1CC2FC5}"/>
+                <a16:creationId xmlns:a16="http://schemas.microsoft.com/office/drawing/2014/main" id="{BF99E539-8FF5-408D-896D-68CD1F35F9EC}"/>
               </a:ext>
             </a:extLst>
           </p:cNvPr>
@@ -7456,7 +7537,7 @@
           <p:cNvPr id="9" name="level-1">
             <a:extLst xmlns:a="http://schemas.openxmlformats.org/drawingml/2006/main">
               <a:ext uri="{FF2B5EF4-FFF2-40B4-BE49-F238E27FC236}">
-                <a16:creationId xmlns:a16="http://schemas.microsoft.com/office/drawing/2014/main" id="{2B3FEB63-71E3-4137-AC2C-A5A5C1AA443A}"/>
+                <a16:creationId xmlns:a16="http://schemas.microsoft.com/office/drawing/2014/main" id="{D4C85ED3-CBA8-4C91-8CB3-FA4442122AF6}"/>
               </a:ext>
             </a:extLst>
           </p:cNvPr>
@@ -7491,7 +7572,7 @@
           <p:cNvPr id="10" name="level-n-bg-1">
             <a:extLst xmlns:a="http://schemas.openxmlformats.org/drawingml/2006/main">
               <a:ext uri="{FF2B5EF4-FFF2-40B4-BE49-F238E27FC236}">
-                <a16:creationId xmlns:a16="http://schemas.microsoft.com/office/drawing/2014/main" id="{B8733B12-F461-4974-95EE-A5F0777AECFA}"/>
+                <a16:creationId xmlns:a16="http://schemas.microsoft.com/office/drawing/2014/main" id="{D948CDEB-C5B7-4E0D-BD09-7D70C5C5A484}"/>
               </a:ext>
             </a:extLst>
           </p:cNvPr>
@@ -7526,7 +7607,7 @@
           <p:cNvPr id="11" name="level-n-1">
             <a:extLst xmlns:a="http://schemas.openxmlformats.org/drawingml/2006/main">
               <a:ext uri="{FF2B5EF4-FFF2-40B4-BE49-F238E27FC236}">
-                <a16:creationId xmlns:a16="http://schemas.microsoft.com/office/drawing/2014/main" id="{81E763D2-247C-4A76-B6BC-94817246C72E}"/>
+                <a16:creationId xmlns:a16="http://schemas.microsoft.com/office/drawing/2014/main" id="{B336C6F3-0A11-4189-873E-6467CB2F8E5A}"/>
               </a:ext>
             </a:extLst>
           </p:cNvPr>
@@ -7584,7 +7665,7 @@
           <p:cNvPr id="12" name="level-title-1">
             <a:extLst xmlns:a="http://schemas.openxmlformats.org/drawingml/2006/main">
               <a:ext uri="{FF2B5EF4-FFF2-40B4-BE49-F238E27FC236}">
-                <a16:creationId xmlns:a16="http://schemas.microsoft.com/office/drawing/2014/main" id="{BF204232-890A-40FC-A3CD-5947BFF4E815}"/>
+                <a16:creationId xmlns:a16="http://schemas.microsoft.com/office/drawing/2014/main" id="{B1A877D6-EEB3-45B0-BABA-C74ED8479B87}"/>
               </a:ext>
             </a:extLst>
           </p:cNvPr>
@@ -7642,7 +7723,7 @@
           <p:cNvPr id="13" name="level-body-1">
             <a:extLst xmlns:a="http://schemas.openxmlformats.org/drawingml/2006/main">
               <a:ext uri="{FF2B5EF4-FFF2-40B4-BE49-F238E27FC236}">
-                <a16:creationId xmlns:a16="http://schemas.microsoft.com/office/drawing/2014/main" id="{CBB1A2ED-653F-49C4-BD6C-68750AD8A9BA}"/>
+                <a16:creationId xmlns:a16="http://schemas.microsoft.com/office/drawing/2014/main" id="{88734E6A-C268-4C91-A732-B47191867C1E}"/>
               </a:ext>
             </a:extLst>
           </p:cNvPr>
@@ -7700,7 +7781,7 @@
           <p:cNvPr id="14" name="level-2">
             <a:extLst xmlns:a="http://schemas.openxmlformats.org/drawingml/2006/main">
               <a:ext uri="{FF2B5EF4-FFF2-40B4-BE49-F238E27FC236}">
-                <a16:creationId xmlns:a16="http://schemas.microsoft.com/office/drawing/2014/main" id="{1FDA0A92-3E7A-41A6-8EE8-D67898BBB3D2}"/>
+                <a16:creationId xmlns:a16="http://schemas.microsoft.com/office/drawing/2014/main" id="{3DD33A50-DD94-44CA-AC83-7694EB3FECBD}"/>
               </a:ext>
             </a:extLst>
           </p:cNvPr>
@@ -7735,7 +7816,7 @@
           <p:cNvPr id="15" name="level-n-bg-2">
             <a:extLst xmlns:a="http://schemas.openxmlformats.org/drawingml/2006/main">
               <a:ext uri="{FF2B5EF4-FFF2-40B4-BE49-F238E27FC236}">
-                <a16:creationId xmlns:a16="http://schemas.microsoft.com/office/drawing/2014/main" id="{DD48AA5C-E501-4996-A8BB-33B6467401D2}"/>
+                <a16:creationId xmlns:a16="http://schemas.microsoft.com/office/drawing/2014/main" id="{98BB32EB-DE00-457D-8D0C-41AA231E9B6F}"/>
               </a:ext>
             </a:extLst>
           </p:cNvPr>
@@ -7770,7 +7851,7 @@
           <p:cNvPr id="16" name="level-n-2">
             <a:extLst xmlns:a="http://schemas.openxmlformats.org/drawingml/2006/main">
               <a:ext uri="{FF2B5EF4-FFF2-40B4-BE49-F238E27FC236}">
-                <a16:creationId xmlns:a16="http://schemas.microsoft.com/office/drawing/2014/main" id="{51623453-88AB-4AF6-BE92-381240F22C4F}"/>
+                <a16:creationId xmlns:a16="http://schemas.microsoft.com/office/drawing/2014/main" id="{CFE6FC74-DA5F-4C71-8126-29C27E64FD0D}"/>
               </a:ext>
             </a:extLst>
           </p:cNvPr>
@@ -7828,7 +7909,7 @@
           <p:cNvPr id="17" name="level-title-2">
             <a:extLst xmlns:a="http://schemas.openxmlformats.org/drawingml/2006/main">
               <a:ext uri="{FF2B5EF4-FFF2-40B4-BE49-F238E27FC236}">
-                <a16:creationId xmlns:a16="http://schemas.microsoft.com/office/drawing/2014/main" id="{932BFAE8-B453-4E5B-AB19-4717BE182D39}"/>
+                <a16:creationId xmlns:a16="http://schemas.microsoft.com/office/drawing/2014/main" id="{46D8F5D7-0BC1-4838-8461-4642C9E302A1}"/>
               </a:ext>
             </a:extLst>
           </p:cNvPr>
@@ -7886,7 +7967,7 @@
           <p:cNvPr id="18" name="level-body-2">
             <a:extLst xmlns:a="http://schemas.openxmlformats.org/drawingml/2006/main">
               <a:ext uri="{FF2B5EF4-FFF2-40B4-BE49-F238E27FC236}">
-                <a16:creationId xmlns:a16="http://schemas.microsoft.com/office/drawing/2014/main" id="{3A982084-3836-4157-B8EB-63F56ABC1CE4}"/>
+                <a16:creationId xmlns:a16="http://schemas.microsoft.com/office/drawing/2014/main" id="{91474AB4-3F90-4837-AC20-4873260F1CA4}"/>
               </a:ext>
             </a:extLst>
           </p:cNvPr>
@@ -7944,7 +8025,7 @@
           <p:cNvPr id="19" name="proof-shot-frame">
             <a:extLst xmlns:a="http://schemas.openxmlformats.org/drawingml/2006/main">
               <a:ext uri="{FF2B5EF4-FFF2-40B4-BE49-F238E27FC236}">
-                <a16:creationId xmlns:a16="http://schemas.microsoft.com/office/drawing/2014/main" id="{C835FEAB-DCDF-476C-8091-D0997406B35D}"/>
+                <a16:creationId xmlns:a16="http://schemas.microsoft.com/office/drawing/2014/main" id="{45A508C4-4336-4312-8EB2-5A6F29F297F8}"/>
               </a:ext>
             </a:extLst>
           </p:cNvPr>
@@ -7983,7 +8064,7 @@
           <p:nvPr/>
         </p:nvPicPr>
         <p:blipFill>
-          <a:blip xmlns:r="http://schemas.openxmlformats.org/officeDocument/2006/relationships" xmlns:a="http://schemas.openxmlformats.org/drawingml/2006/main" r:embed="Ra9c152d7096a4184"/>
+          <a:blip xmlns:r="http://schemas.openxmlformats.org/officeDocument/2006/relationships" xmlns:a="http://schemas.openxmlformats.org/drawingml/2006/main" r:embed="Rbd5c52bb25d74c41"/>
           <a:stretch xmlns:a="http://schemas.openxmlformats.org/drawingml/2006/main"/>
         </p:blipFill>
         <p:spPr>
@@ -8003,7 +8084,7 @@
           <p:cNvPr id="21" name="page-6">
             <a:extLst xmlns:a="http://schemas.openxmlformats.org/drawingml/2006/main">
               <a:ext uri="{FF2B5EF4-FFF2-40B4-BE49-F238E27FC236}">
-                <a16:creationId xmlns:a16="http://schemas.microsoft.com/office/drawing/2014/main" id="{A2147B48-F2A1-4D42-B920-3D87E721F478}"/>
+                <a16:creationId xmlns:a16="http://schemas.microsoft.com/office/drawing/2014/main" id="{1750D051-8549-4756-B8A3-92279DDB15B4}"/>
               </a:ext>
             </a:extLst>
           </p:cNvPr>
@@ -8059,7 +8140,7 @@
     </p:spTree>
     <p:extLst>
       <p:ext uri="{BB962C8B-B14F-4D97-AF65-F5344CB8AC3E}">
-        <p14:creationId xmlns:p14="http://schemas.microsoft.com/office/powerpoint/2010/main" val="1492376681"/>
+        <p14:creationId xmlns:p14="http://schemas.microsoft.com/office/powerpoint/2010/main" val="1554621715"/>
       </p:ext>
     </p:extLst>
   </p:cSld>
@@ -8090,7 +8171,7 @@
           <p:cNvPr id="16" name="Google-Shape-532-p58-2">
             <a:extLst xmlns:a="http://schemas.openxmlformats.org/drawingml/2006/main">
               <a:ext uri="{FF2B5EF4-FFF2-40B4-BE49-F238E27FC236}">
-                <a16:creationId xmlns:a16="http://schemas.microsoft.com/office/drawing/2014/main" id="{9211A8BD-59EA-40AA-BA96-043D6CFAB97C}"/>
+                <a16:creationId xmlns:a16="http://schemas.microsoft.com/office/drawing/2014/main" id="{4A7A14BD-E7F4-4A6E-953A-5C6678C1E947}"/>
               </a:ext>
             </a:extLst>
           </p:cNvPr>
@@ -8135,7 +8216,7 @@
           <p:cNvPr id="2" name="Google-Shape-533-p58-3">
             <a:extLst xmlns:a="http://schemas.openxmlformats.org/drawingml/2006/main">
               <a:ext uri="{FF2B5EF4-FFF2-40B4-BE49-F238E27FC236}">
-                <a16:creationId xmlns:a16="http://schemas.microsoft.com/office/drawing/2014/main" id="{2D04D509-E2C6-4E0D-B587-71E40909F41E}"/>
+                <a16:creationId xmlns:a16="http://schemas.microsoft.com/office/drawing/2014/main" id="{191B7540-249A-4376-8591-99988DC09AE8}"/>
               </a:ext>
             </a:extLst>
           </p:cNvPr>
@@ -8180,7 +8261,7 @@
           <p:cNvPr id="3" name="Rounded-Rectangle-6-4">
             <a:extLst xmlns:a="http://schemas.openxmlformats.org/drawingml/2006/main">
               <a:ext uri="{FF2B5EF4-FFF2-40B4-BE49-F238E27FC236}">
-                <a16:creationId xmlns:a16="http://schemas.microsoft.com/office/drawing/2014/main" id="{F453C4D9-0A43-4B27-A371-466BF917DEBA}"/>
+                <a16:creationId xmlns:a16="http://schemas.microsoft.com/office/drawing/2014/main" id="{041068AB-464A-48F6-B360-9DBCC116EC8C}"/>
               </a:ext>
             </a:extLst>
           </p:cNvPr>
@@ -8209,7 +8290,7 @@
           <p:cNvPr id="4" name="Content-Placeholder-10-5">
             <a:extLst xmlns:a="http://schemas.openxmlformats.org/drawingml/2006/main">
               <a:ext uri="{FF2B5EF4-FFF2-40B4-BE49-F238E27FC236}">
-                <a16:creationId xmlns:a16="http://schemas.microsoft.com/office/drawing/2014/main" id="{A3AED155-32D8-4463-BA2E-ED39F063FD77}"/>
+                <a16:creationId xmlns:a16="http://schemas.microsoft.com/office/drawing/2014/main" id="{96CD91F1-BE66-440C-9D41-8631A0F4F347}"/>
               </a:ext>
             </a:extLst>
           </p:cNvPr>
@@ -8269,7 +8350,7 @@
           <p:cNvPr id="5" name="Rounded-Rectangle-8-6">
             <a:extLst xmlns:a="http://schemas.openxmlformats.org/drawingml/2006/main">
               <a:ext uri="{FF2B5EF4-FFF2-40B4-BE49-F238E27FC236}">
-                <a16:creationId xmlns:a16="http://schemas.microsoft.com/office/drawing/2014/main" id="{D3436A41-A45D-4AAB-A114-2CE08227B5C1}"/>
+                <a16:creationId xmlns:a16="http://schemas.microsoft.com/office/drawing/2014/main" id="{40E84084-4470-4105-B54E-D7D03B47F051}"/>
               </a:ext>
             </a:extLst>
           </p:cNvPr>
@@ -8298,7 +8379,7 @@
           <p:cNvPr id="6" name="Content-Placeholder-10-7">
             <a:extLst xmlns:a="http://schemas.openxmlformats.org/drawingml/2006/main">
               <a:ext uri="{FF2B5EF4-FFF2-40B4-BE49-F238E27FC236}">
-                <a16:creationId xmlns:a16="http://schemas.microsoft.com/office/drawing/2014/main" id="{E4CFBBE7-F51E-4B36-A08A-01AD6BD64546}"/>
+                <a16:creationId xmlns:a16="http://schemas.microsoft.com/office/drawing/2014/main" id="{E2FA8095-F4FF-4D94-85F3-927FC3A45726}"/>
               </a:ext>
             </a:extLst>
           </p:cNvPr>
@@ -8358,7 +8439,7 @@
           <p:cNvPr id="7" name="Rounded-Rectangle-1-8">
             <a:extLst xmlns:a="http://schemas.openxmlformats.org/drawingml/2006/main">
               <a:ext uri="{FF2B5EF4-FFF2-40B4-BE49-F238E27FC236}">
-                <a16:creationId xmlns:a16="http://schemas.microsoft.com/office/drawing/2014/main" id="{A5C3E1FC-1FA0-483C-A471-FB52B79C2621}"/>
+                <a16:creationId xmlns:a16="http://schemas.microsoft.com/office/drawing/2014/main" id="{FAB48AB1-C9C0-42C9-8A0E-48F28F6F58F4}"/>
               </a:ext>
             </a:extLst>
           </p:cNvPr>
@@ -8387,7 +8468,7 @@
           <p:cNvPr id="8" name="Content-Placeholder-10-9">
             <a:extLst xmlns:a="http://schemas.openxmlformats.org/drawingml/2006/main">
               <a:ext uri="{FF2B5EF4-FFF2-40B4-BE49-F238E27FC236}">
-                <a16:creationId xmlns:a16="http://schemas.microsoft.com/office/drawing/2014/main" id="{B3B2587D-F0DE-4C8E-8357-7012AAB26263}"/>
+                <a16:creationId xmlns:a16="http://schemas.microsoft.com/office/drawing/2014/main" id="{DB5EA3E3-5157-4F9C-B5B7-D52DEF34B64B}"/>
               </a:ext>
             </a:extLst>
           </p:cNvPr>
@@ -8447,7 +8528,7 @@
           <p:cNvPr id="9" name="Rounded-Rectangle-3-10">
             <a:extLst xmlns:a="http://schemas.openxmlformats.org/drawingml/2006/main">
               <a:ext uri="{FF2B5EF4-FFF2-40B4-BE49-F238E27FC236}">
-                <a16:creationId xmlns:a16="http://schemas.microsoft.com/office/drawing/2014/main" id="{08D4E4DD-389E-4ACB-8CA9-482674F3A22C}"/>
+                <a16:creationId xmlns:a16="http://schemas.microsoft.com/office/drawing/2014/main" id="{1B82FEF4-8F1F-4E44-9F1D-97FCBDB87DDA}"/>
               </a:ext>
             </a:extLst>
           </p:cNvPr>
@@ -8476,7 +8557,7 @@
           <p:cNvPr id="10" name="Content-Placeholder-10-11">
             <a:extLst xmlns:a="http://schemas.openxmlformats.org/drawingml/2006/main">
               <a:ext uri="{FF2B5EF4-FFF2-40B4-BE49-F238E27FC236}">
-                <a16:creationId xmlns:a16="http://schemas.microsoft.com/office/drawing/2014/main" id="{BE3EA673-B68E-4212-84D6-59856633EB04}"/>
+                <a16:creationId xmlns:a16="http://schemas.microsoft.com/office/drawing/2014/main" id="{E04A5810-DD31-4419-B23B-5B947383EBFC}"/>
               </a:ext>
             </a:extLst>
           </p:cNvPr>
@@ -8536,7 +8617,7 @@
           <p:cNvPr id="11" name="Content-Placeholder-15-12">
             <a:extLst xmlns:a="http://schemas.openxmlformats.org/drawingml/2006/main">
               <a:ext uri="{FF2B5EF4-FFF2-40B4-BE49-F238E27FC236}">
-                <a16:creationId xmlns:a16="http://schemas.microsoft.com/office/drawing/2014/main" id="{7D12C5EC-DAEB-4D6E-995D-C6F4893987F6}"/>
+                <a16:creationId xmlns:a16="http://schemas.microsoft.com/office/drawing/2014/main" id="{75310FF5-B5AA-45D4-9951-9D3023ADA15D}"/>
               </a:ext>
             </a:extLst>
           </p:cNvPr>
@@ -8596,7 +8677,7 @@
           <p:cNvPr id="12" name="engine-accent-0">
             <a:extLst xmlns:a="http://schemas.openxmlformats.org/drawingml/2006/main">
               <a:ext uri="{FF2B5EF4-FFF2-40B4-BE49-F238E27FC236}">
-                <a16:creationId xmlns:a16="http://schemas.microsoft.com/office/drawing/2014/main" id="{647D2FA9-2ADB-48FC-A86A-D03066428E9E}"/>
+                <a16:creationId xmlns:a16="http://schemas.microsoft.com/office/drawing/2014/main" id="{4FD571CF-CED8-4633-9726-4584F35F49F1}"/>
               </a:ext>
             </a:extLst>
           </p:cNvPr>
@@ -8631,7 +8712,7 @@
           <p:cNvPr id="13" name="engine-accent-1">
             <a:extLst xmlns:a="http://schemas.openxmlformats.org/drawingml/2006/main">
               <a:ext uri="{FF2B5EF4-FFF2-40B4-BE49-F238E27FC236}">
-                <a16:creationId xmlns:a16="http://schemas.microsoft.com/office/drawing/2014/main" id="{D9C18BE5-6E83-4267-B887-991BD5C9A695}"/>
+                <a16:creationId xmlns:a16="http://schemas.microsoft.com/office/drawing/2014/main" id="{6C39D95C-4403-4D76-9DB1-0427C89C89D2}"/>
               </a:ext>
             </a:extLst>
           </p:cNvPr>
@@ -8666,7 +8747,7 @@
           <p:cNvPr id="14" name="engine-accent-2">
             <a:extLst xmlns:a="http://schemas.openxmlformats.org/drawingml/2006/main">
               <a:ext uri="{FF2B5EF4-FFF2-40B4-BE49-F238E27FC236}">
-                <a16:creationId xmlns:a16="http://schemas.microsoft.com/office/drawing/2014/main" id="{1BE1F0C7-35CB-4BEC-B577-C16441E55B14}"/>
+                <a16:creationId xmlns:a16="http://schemas.microsoft.com/office/drawing/2014/main" id="{DBA5B4FF-A6D5-4CCA-B649-32DC053F4925}"/>
               </a:ext>
             </a:extLst>
           </p:cNvPr>
@@ -8701,7 +8782,7 @@
           <p:cNvPr id="15" name="engine-accent-3">
             <a:extLst xmlns:a="http://schemas.openxmlformats.org/drawingml/2006/main">
               <a:ext uri="{FF2B5EF4-FFF2-40B4-BE49-F238E27FC236}">
-                <a16:creationId xmlns:a16="http://schemas.microsoft.com/office/drawing/2014/main" id="{0E6A9B24-40F4-44C0-BC13-17DC7F5326E6}"/>
+                <a16:creationId xmlns:a16="http://schemas.microsoft.com/office/drawing/2014/main" id="{1C283F96-0EE3-4419-A062-4EA695E17C7D}"/>
               </a:ext>
             </a:extLst>
           </p:cNvPr>
@@ -8734,7 +8815,7 @@
     </p:spTree>
     <p:extLst>
       <p:ext uri="{BB962C8B-B14F-4D97-AF65-F5344CB8AC3E}">
-        <p14:creationId xmlns:p14="http://schemas.microsoft.com/office/powerpoint/2010/main" val="1731750375"/>
+        <p14:creationId xmlns:p14="http://schemas.microsoft.com/office/powerpoint/2010/main" val="163881664"/>
       </p:ext>
     </p:extLst>
   </p:cSld>
@@ -8765,7 +8846,7 @@
           <p:cNvPr id="14" name="Değer-eyebrow">
             <a:extLst xmlns:a="http://schemas.openxmlformats.org/drawingml/2006/main">
               <a:ext uri="{FF2B5EF4-FFF2-40B4-BE49-F238E27FC236}">
-                <a16:creationId xmlns:a16="http://schemas.microsoft.com/office/drawing/2014/main" id="{ED900196-71D9-48EF-B621-0F9D3E0465CA}"/>
+                <a16:creationId xmlns:a16="http://schemas.microsoft.com/office/drawing/2014/main" id="{D28A596F-79A6-4601-B834-9487BC5B58C2}"/>
               </a:ext>
             </a:extLst>
           </p:cNvPr>
@@ -8823,7 +8904,7 @@
           <p:cNvPr id="2" name="Değer-title">
             <a:extLst xmlns:a="http://schemas.openxmlformats.org/drawingml/2006/main">
               <a:ext uri="{FF2B5EF4-FFF2-40B4-BE49-F238E27FC236}">
-                <a16:creationId xmlns:a16="http://schemas.microsoft.com/office/drawing/2014/main" id="{273622BD-9429-4CC1-A63F-0D7ED065BE83}"/>
+                <a16:creationId xmlns:a16="http://schemas.microsoft.com/office/drawing/2014/main" id="{2F98CF2B-9ED4-4821-A0DB-A6CAB24706A9}"/>
               </a:ext>
             </a:extLst>
           </p:cNvPr>
@@ -8881,7 +8962,7 @@
           <p:cNvPr id="3" name="Değer-subtitle">
             <a:extLst xmlns:a="http://schemas.openxmlformats.org/drawingml/2006/main">
               <a:ext uri="{FF2B5EF4-FFF2-40B4-BE49-F238E27FC236}">
-                <a16:creationId xmlns:a16="http://schemas.microsoft.com/office/drawing/2014/main" id="{8185B7A9-207D-4BDD-A206-B76502EEDA79}"/>
+                <a16:creationId xmlns:a16="http://schemas.microsoft.com/office/drawing/2014/main" id="{21040553-F78D-44E1-8AFB-D97680E77467}"/>
               </a:ext>
             </a:extLst>
           </p:cNvPr>
@@ -8939,7 +9020,7 @@
           <p:cNvPr id="4" name="not-nav">
             <a:extLst xmlns:a="http://schemas.openxmlformats.org/drawingml/2006/main">
               <a:ext uri="{FF2B5EF4-FFF2-40B4-BE49-F238E27FC236}">
-                <a16:creationId xmlns:a16="http://schemas.microsoft.com/office/drawing/2014/main" id="{4BA09300-BB9C-4C5A-8C43-07F78373B100}"/>
+                <a16:creationId xmlns:a16="http://schemas.microsoft.com/office/drawing/2014/main" id="{040DC827-59BF-4CB1-B376-ADAF058F44CA}"/>
               </a:ext>
             </a:extLst>
           </p:cNvPr>
@@ -8974,7 +9055,7 @@
           <p:cNvPr id="5" name="not-nav-kicker">
             <a:extLst xmlns:a="http://schemas.openxmlformats.org/drawingml/2006/main">
               <a:ext uri="{FF2B5EF4-FFF2-40B4-BE49-F238E27FC236}">
-                <a16:creationId xmlns:a16="http://schemas.microsoft.com/office/drawing/2014/main" id="{E1B22E65-F96D-4973-9B91-AE1BF58E6B4D}"/>
+                <a16:creationId xmlns:a16="http://schemas.microsoft.com/office/drawing/2014/main" id="{89B95DCA-5DB2-449F-838D-CE19E918E1ED}"/>
               </a:ext>
             </a:extLst>
           </p:cNvPr>
@@ -9032,7 +9113,7 @@
           <p:cNvPr id="6" name="not-nav-title">
             <a:extLst xmlns:a="http://schemas.openxmlformats.org/drawingml/2006/main">
               <a:ext uri="{FF2B5EF4-FFF2-40B4-BE49-F238E27FC236}">
-                <a16:creationId xmlns:a16="http://schemas.microsoft.com/office/drawing/2014/main" id="{3360D8A3-B8F4-427F-B389-F11D8C176F60}"/>
+                <a16:creationId xmlns:a16="http://schemas.microsoft.com/office/drawing/2014/main" id="{14181DBC-D92C-45A1-BB2E-EFA755EF1476}"/>
               </a:ext>
             </a:extLst>
           </p:cNvPr>
@@ -9090,7 +9171,7 @@
           <p:cNvPr id="7" name="not-nav-body">
             <a:extLst xmlns:a="http://schemas.openxmlformats.org/drawingml/2006/main">
               <a:ext uri="{FF2B5EF4-FFF2-40B4-BE49-F238E27FC236}">
-                <a16:creationId xmlns:a16="http://schemas.microsoft.com/office/drawing/2014/main" id="{B272A2D7-55C2-44C3-ACEF-DD07E54E131B}"/>
+                <a16:creationId xmlns:a16="http://schemas.microsoft.com/office/drawing/2014/main" id="{C84A44EB-5886-43F4-9EE8-06BAA7744B1B}"/>
               </a:ext>
             </a:extLst>
           </p:cNvPr>
@@ -9194,7 +9275,7 @@
           <p:cNvPr id="8" name="is-lab">
             <a:extLst xmlns:a="http://schemas.openxmlformats.org/drawingml/2006/main">
               <a:ext uri="{FF2B5EF4-FFF2-40B4-BE49-F238E27FC236}">
-                <a16:creationId xmlns:a16="http://schemas.microsoft.com/office/drawing/2014/main" id="{68D45004-6760-4884-85D1-A41A07AFA672}"/>
+                <a16:creationId xmlns:a16="http://schemas.microsoft.com/office/drawing/2014/main" id="{BF5D00FA-1576-4616-A239-C7948E0D706F}"/>
               </a:ext>
             </a:extLst>
           </p:cNvPr>
@@ -9229,7 +9310,7 @@
           <p:cNvPr id="9" name="is-lab-kicker">
             <a:extLst xmlns:a="http://schemas.openxmlformats.org/drawingml/2006/main">
               <a:ext uri="{FF2B5EF4-FFF2-40B4-BE49-F238E27FC236}">
-                <a16:creationId xmlns:a16="http://schemas.microsoft.com/office/drawing/2014/main" id="{B27E6235-DDD4-4A1B-AE3A-BC54662C4A53}"/>
+                <a16:creationId xmlns:a16="http://schemas.microsoft.com/office/drawing/2014/main" id="{6E835C23-F211-4D22-BB49-B7423781AFCE}"/>
               </a:ext>
             </a:extLst>
           </p:cNvPr>
@@ -9287,7 +9368,7 @@
           <p:cNvPr id="10" name="is-lab-title">
             <a:extLst xmlns:a="http://schemas.openxmlformats.org/drawingml/2006/main">
               <a:ext uri="{FF2B5EF4-FFF2-40B4-BE49-F238E27FC236}">
-                <a16:creationId xmlns:a16="http://schemas.microsoft.com/office/drawing/2014/main" id="{C247200F-C9B0-47CF-81DF-6B09CD0592F6}"/>
+                <a16:creationId xmlns:a16="http://schemas.microsoft.com/office/drawing/2014/main" id="{4C8CFF64-B930-46DC-A0BE-86D825E178EF}"/>
               </a:ext>
             </a:extLst>
           </p:cNvPr>
@@ -9345,7 +9426,7 @@
           <p:cNvPr id="11" name="is-lab-body">
             <a:extLst xmlns:a="http://schemas.openxmlformats.org/drawingml/2006/main">
               <a:ext uri="{FF2B5EF4-FFF2-40B4-BE49-F238E27FC236}">
-                <a16:creationId xmlns:a16="http://schemas.microsoft.com/office/drawing/2014/main" id="{58C7E0A3-5B6D-4005-B946-E4CA58DA8725}"/>
+                <a16:creationId xmlns:a16="http://schemas.microsoft.com/office/drawing/2014/main" id="{E1F5955C-672B-4223-A63C-B8DC5F93A889}"/>
               </a:ext>
             </a:extLst>
           </p:cNvPr>
@@ -9449,7 +9530,7 @@
           <p:cNvPr id="12" name="users">
             <a:extLst xmlns:a="http://schemas.openxmlformats.org/drawingml/2006/main">
               <a:ext uri="{FF2B5EF4-FFF2-40B4-BE49-F238E27FC236}">
-                <a16:creationId xmlns:a16="http://schemas.microsoft.com/office/drawing/2014/main" id="{E30F475C-425F-414A-A674-89EFD20E0439}"/>
+                <a16:creationId xmlns:a16="http://schemas.microsoft.com/office/drawing/2014/main" id="{83D7567A-33F1-4C5F-B0E8-B9DFA3255DB2}"/>
               </a:ext>
             </a:extLst>
           </p:cNvPr>
@@ -9507,7 +9588,7 @@
           <p:cNvPr id="13" name="page-8">
             <a:extLst xmlns:a="http://schemas.openxmlformats.org/drawingml/2006/main">
               <a:ext uri="{FF2B5EF4-FFF2-40B4-BE49-F238E27FC236}">
-                <a16:creationId xmlns:a16="http://schemas.microsoft.com/office/drawing/2014/main" id="{03EDDE59-3A8C-4A5E-A6B7-94CDE5FFCCFE}"/>
+                <a16:creationId xmlns:a16="http://schemas.microsoft.com/office/drawing/2014/main" id="{8576BB29-B3F8-4094-BC79-59A966F905D6}"/>
               </a:ext>
             </a:extLst>
           </p:cNvPr>
@@ -9563,7 +9644,7 @@
     </p:spTree>
     <p:extLst>
       <p:ext uri="{BB962C8B-B14F-4D97-AF65-F5344CB8AC3E}">
-        <p14:creationId xmlns:p14="http://schemas.microsoft.com/office/powerpoint/2010/main" val="1834260132"/>
+        <p14:creationId xmlns:p14="http://schemas.microsoft.com/office/powerpoint/2010/main" val="2077558108"/>
       </p:ext>
     </p:extLst>
   </p:cSld>
@@ -9594,7 +9675,7 @@
           <p:cNvPr id="17" name="Slide-Number-Placeholder-3-2">
             <a:extLst xmlns:a="http://schemas.openxmlformats.org/drawingml/2006/main">
               <a:ext uri="{FF2B5EF4-FFF2-40B4-BE49-F238E27FC236}">
-                <a16:creationId xmlns:a16="http://schemas.microsoft.com/office/drawing/2014/main" id="{4125760C-6434-4C88-B4D1-1A634CB07498}"/>
+                <a16:creationId xmlns:a16="http://schemas.microsoft.com/office/drawing/2014/main" id="{2BC505CA-A839-4730-A30F-2FE11E16AD7A}"/>
               </a:ext>
             </a:extLst>
           </p:cNvPr>
@@ -9637,7 +9718,7 @@
           <p:cNvPr id="2" name="Title-10-3">
             <a:extLst xmlns:a="http://schemas.openxmlformats.org/drawingml/2006/main">
               <a:ext uri="{FF2B5EF4-FFF2-40B4-BE49-F238E27FC236}">
-                <a16:creationId xmlns:a16="http://schemas.microsoft.com/office/drawing/2014/main" id="{43FFC5AF-0102-4824-B61F-051EB9AAC0B2}"/>
+                <a16:creationId xmlns:a16="http://schemas.microsoft.com/office/drawing/2014/main" id="{02C30447-6819-4F3E-8D99-32F3E9447ACE}"/>
               </a:ext>
             </a:extLst>
           </p:cNvPr>
@@ -9704,7 +9785,7 @@
           <p:cNvPr id="4" name="Google-Shape-2260-p159-5">
             <a:extLst xmlns:a="http://schemas.openxmlformats.org/drawingml/2006/main">
               <a:ext uri="{FF2B5EF4-FFF2-40B4-BE49-F238E27FC236}">
-                <a16:creationId xmlns:a16="http://schemas.microsoft.com/office/drawing/2014/main" id="{F3709362-D50E-45A6-8A75-1BC87B3DC2B8}"/>
+                <a16:creationId xmlns:a16="http://schemas.microsoft.com/office/drawing/2014/main" id="{84F29173-6551-426B-8FB2-CD577ED9102E}"/>
               </a:ext>
             </a:extLst>
           </p:cNvPr>
@@ -9731,7 +9812,7 @@
           <p:cNvPr id="5" name="Google-Shape-2261-p159-6">
             <a:extLst xmlns:a="http://schemas.openxmlformats.org/drawingml/2006/main">
               <a:ext uri="{FF2B5EF4-FFF2-40B4-BE49-F238E27FC236}">
-                <a16:creationId xmlns:a16="http://schemas.microsoft.com/office/drawing/2014/main" id="{3800512E-7A0D-4D88-AD57-F9194F1F81A9}"/>
+                <a16:creationId xmlns:a16="http://schemas.microsoft.com/office/drawing/2014/main" id="{C6981F13-7F97-40E3-8804-4B9C418A57CE}"/>
               </a:ext>
             </a:extLst>
           </p:cNvPr>
@@ -9758,7 +9839,7 @@
           <p:cNvPr id="6" name="Google-Shape-2262-p159-7">
             <a:extLst xmlns:a="http://schemas.openxmlformats.org/drawingml/2006/main">
               <a:ext uri="{FF2B5EF4-FFF2-40B4-BE49-F238E27FC236}">
-                <a16:creationId xmlns:a16="http://schemas.microsoft.com/office/drawing/2014/main" id="{8E33DD57-C6CF-48B7-8B6F-7765E24DA550}"/>
+                <a16:creationId xmlns:a16="http://schemas.microsoft.com/office/drawing/2014/main" id="{1D1E8664-04C5-495B-85BE-0BB30F048AEE}"/>
               </a:ext>
             </a:extLst>
           </p:cNvPr>
@@ -9785,7 +9866,7 @@
           <p:cNvPr id="7" name="Content-Placeholder-15-8">
             <a:extLst xmlns:a="http://schemas.openxmlformats.org/drawingml/2006/main">
               <a:ext uri="{FF2B5EF4-FFF2-40B4-BE49-F238E27FC236}">
-                <a16:creationId xmlns:a16="http://schemas.microsoft.com/office/drawing/2014/main" id="{2B526BF8-EED7-43E0-BEB0-6136228660FF}"/>
+                <a16:creationId xmlns:a16="http://schemas.microsoft.com/office/drawing/2014/main" id="{C895FA2A-9675-47CB-8CAC-DB86E9F6B25B}"/>
               </a:ext>
             </a:extLst>
           </p:cNvPr>
@@ -9830,7 +9911,7 @@
           <p:cNvPr id="8" name="Content-Placeholder-15-9">
             <a:extLst xmlns:a="http://schemas.openxmlformats.org/drawingml/2006/main">
               <a:ext uri="{FF2B5EF4-FFF2-40B4-BE49-F238E27FC236}">
-                <a16:creationId xmlns:a16="http://schemas.microsoft.com/office/drawing/2014/main" id="{6B255793-79DD-43DC-BFD7-AE66B3726025}"/>
+                <a16:creationId xmlns:a16="http://schemas.microsoft.com/office/drawing/2014/main" id="{9E6DC067-0339-4756-972E-A3637458B83E}"/>
               </a:ext>
             </a:extLst>
           </p:cNvPr>
@@ -9875,7 +9956,7 @@
           <p:cNvPr id="9" name="Content-Placeholder-15-10">
             <a:extLst xmlns:a="http://schemas.openxmlformats.org/drawingml/2006/main">
               <a:ext uri="{FF2B5EF4-FFF2-40B4-BE49-F238E27FC236}">
-                <a16:creationId xmlns:a16="http://schemas.microsoft.com/office/drawing/2014/main" id="{96AE0224-F8F6-4B12-8CA7-D882144411E8}"/>
+                <a16:creationId xmlns:a16="http://schemas.microsoft.com/office/drawing/2014/main" id="{DAE33F58-B8BD-4099-A128-B9DDCA48BCC0}"/>
               </a:ext>
             </a:extLst>
           </p:cNvPr>
@@ -9920,7 +10001,7 @@
           <p:cNvPr id="10" name="Text-Placeholder-16-11">
             <a:extLst xmlns:a="http://schemas.openxmlformats.org/drawingml/2006/main">
               <a:ext uri="{FF2B5EF4-FFF2-40B4-BE49-F238E27FC236}">
-                <a16:creationId xmlns:a16="http://schemas.microsoft.com/office/drawing/2014/main" id="{DE4E616F-494E-4538-9C3A-E7846A114D5C}"/>
+                <a16:creationId xmlns:a16="http://schemas.microsoft.com/office/drawing/2014/main" id="{36D88DAC-95B1-4CFD-9C5A-4220D4DF08D0}"/>
               </a:ext>
             </a:extLst>
           </p:cNvPr>
@@ -9996,7 +10077,7 @@
           <p:cNvPr id="11" name="Text-Placeholder-16-12">
             <a:extLst xmlns:a="http://schemas.openxmlformats.org/drawingml/2006/main">
               <a:ext uri="{FF2B5EF4-FFF2-40B4-BE49-F238E27FC236}">
-                <a16:creationId xmlns:a16="http://schemas.microsoft.com/office/drawing/2014/main" id="{97AA3228-6070-45AD-9A3A-274E9FC24F21}"/>
+                <a16:creationId xmlns:a16="http://schemas.microsoft.com/office/drawing/2014/main" id="{05BCDA66-7706-4C57-BDEC-7BF3BE337357}"/>
               </a:ext>
             </a:extLst>
           </p:cNvPr>
@@ -10072,7 +10153,7 @@
           <p:cNvPr id="12" name="Text-Placeholder-16-13">
             <a:extLst xmlns:a="http://schemas.openxmlformats.org/drawingml/2006/main">
               <a:ext uri="{FF2B5EF4-FFF2-40B4-BE49-F238E27FC236}">
-                <a16:creationId xmlns:a16="http://schemas.microsoft.com/office/drawing/2014/main" id="{00ECC42F-B67D-4FC0-AA20-4FA206467C14}"/>
+                <a16:creationId xmlns:a16="http://schemas.microsoft.com/office/drawing/2014/main" id="{846B6A1A-383E-427D-A88E-44E692BD605B}"/>
               </a:ext>
             </a:extLst>
           </p:cNvPr>
@@ -10148,7 +10229,7 @@
           <p:cNvPr id="13" name="tag-NL → problem modeli">
             <a:extLst xmlns:a="http://schemas.openxmlformats.org/drawingml/2006/main">
               <a:ext uri="{FF2B5EF4-FFF2-40B4-BE49-F238E27FC236}">
-                <a16:creationId xmlns:a16="http://schemas.microsoft.com/office/drawing/2014/main" id="{E3CC518E-C77D-4A17-8FF6-7A941968AAC6}"/>
+                <a16:creationId xmlns:a16="http://schemas.microsoft.com/office/drawing/2014/main" id="{ACAEFD75-E80B-4F38-9DBC-1A7CD9B1D9B2}"/>
               </a:ext>
             </a:extLst>
           </p:cNvPr>
@@ -10183,7 +10264,7 @@
           <p:cNvPr id="14" name="tag-text-NL → problem modeli">
             <a:extLst xmlns:a="http://schemas.openxmlformats.org/drawingml/2006/main">
               <a:ext uri="{FF2B5EF4-FFF2-40B4-BE49-F238E27FC236}">
-                <a16:creationId xmlns:a16="http://schemas.microsoft.com/office/drawing/2014/main" id="{DB9C1533-1416-4F0C-93FF-6A29B0766D27}"/>
+                <a16:creationId xmlns:a16="http://schemas.microsoft.com/office/drawing/2014/main" id="{FB5AAB3A-C61D-4920-A390-569E1D6D0F2E}"/>
               </a:ext>
             </a:extLst>
           </p:cNvPr>
@@ -10241,7 +10322,7 @@
           <p:cNvPr id="15" name="tag-NP-zor problem galerisi">
             <a:extLst xmlns:a="http://schemas.openxmlformats.org/drawingml/2006/main">
               <a:ext uri="{FF2B5EF4-FFF2-40B4-BE49-F238E27FC236}">
-                <a16:creationId xmlns:a16="http://schemas.microsoft.com/office/drawing/2014/main" id="{C02BB8EB-E2AB-4E39-81A3-0ADE936E63E7}"/>
+                <a16:creationId xmlns:a16="http://schemas.microsoft.com/office/drawing/2014/main" id="{BA35A5C1-EDF6-4F10-B27F-92FDA94A36F6}"/>
               </a:ext>
             </a:extLst>
           </p:cNvPr>
@@ -10276,7 +10357,7 @@
           <p:cNvPr id="16" name="tag-text-NP-zor problem galerisi">
             <a:extLst xmlns:a="http://schemas.openxmlformats.org/drawingml/2006/main">
               <a:ext uri="{FF2B5EF4-FFF2-40B4-BE49-F238E27FC236}">
-                <a16:creationId xmlns:a16="http://schemas.microsoft.com/office/drawing/2014/main" id="{BA065EAA-C847-4619-BCDE-460E3E62B8E8}"/>
+                <a16:creationId xmlns:a16="http://schemas.microsoft.com/office/drawing/2014/main" id="{8C071B94-AA98-4989-80F6-7CA57200AE0E}"/>
               </a:ext>
             </a:extLst>
           </p:cNvPr>
@@ -10332,7 +10413,7 @@
     </p:spTree>
     <p:extLst>
       <p:ext uri="{BB962C8B-B14F-4D97-AF65-F5344CB8AC3E}">
-        <p14:creationId xmlns:p14="http://schemas.microsoft.com/office/powerpoint/2010/main" val="1333224329"/>
+        <p14:creationId xmlns:p14="http://schemas.microsoft.com/office/powerpoint/2010/main" val="1397591362"/>
       </p:ext>
     </p:extLst>
   </p:cSld>

</xml_diff>